<commit_message>
feat: add DogFlush presentation file to project directory
</commit_message>
<xml_diff>
--- a/Projeto/DogFlush_Apresentacao.pptx
+++ b/Projeto/DogFlush_Apresentacao.pptx
@@ -7648,7 +7648,7 @@
         </p:nvSpPr>
         <p:spPr>
           <a:xfrm>
-            <a:off x="731520" y="1371600"/>
+            <a:off x="731520" y="456385"/>
             <a:ext cx="7680960" cy="1097280"/>
           </a:xfrm>
           <a:prstGeom prst="rect">
@@ -7676,45 +7676,6 @@
               <a:t>Demonstração</a:t>
             </a:r>
             <a:endParaRPr lang="en-US" sz="4000" dirty="0"/>
-          </a:p>
-        </p:txBody>
-      </p:sp>
-      <p:sp>
-        <p:nvSpPr>
-          <p:cNvPr id="3" name="Text 1"/>
-          <p:cNvSpPr/>
-          <p:nvPr/>
-        </p:nvSpPr>
-        <p:spPr>
-          <a:xfrm>
-            <a:off x="731520" y="2468880"/>
-            <a:ext cx="7680960" cy="548640"/>
-          </a:xfrm>
-          <a:prstGeom prst="rect">
-            <a:avLst/>
-          </a:prstGeom>
-          <a:noFill/>
-          <a:ln/>
-        </p:spPr>
-        <p:txBody>
-          <a:bodyPr wrap="square" lIns="0" tIns="0" rIns="0" bIns="0" rtlCol="0" anchor="ctr"/>
-          <a:lstStyle/>
-          <a:p>
-            <a:pPr marL="0" indent="0">
-              <a:buNone/>
-            </a:pPr>
-            <a:r>
-              <a:rPr lang="en-US" sz="1800" dirty="0">
-                <a:solidFill>
-                  <a:srgbClr val="80CBC4"/>
-                </a:solidFill>
-                <a:latin typeface="Calibri" pitchFamily="34" charset="0"/>
-                <a:ea typeface="Calibri" pitchFamily="34" charset="-122"/>
-                <a:cs typeface="Calibri" pitchFamily="34" charset="-120"/>
-              </a:rPr>
-              <a:t>Vídeo de execução + Demo ao vivo com webcam</a:t>
-            </a:r>
-            <a:endParaRPr lang="en-US" sz="1800" dirty="0"/>
           </a:p>
         </p:txBody>
       </p:sp>
@@ -7747,140 +7708,289 @@
           </a:p>
         </p:txBody>
       </p:sp>
+      <p:sp>
+        <p:nvSpPr>
+          <p:cNvPr id="6" name="Shape 3"/>
+          <p:cNvSpPr/>
+          <p:nvPr/>
+        </p:nvSpPr>
+        <p:spPr>
+          <a:xfrm>
+            <a:off x="0" y="4800600"/>
+            <a:ext cx="9144000" cy="342900"/>
+          </a:xfrm>
+          <a:prstGeom prst="rect">
+            <a:avLst/>
+          </a:prstGeom>
+          <a:solidFill>
+            <a:srgbClr val="003F2D"/>
+          </a:solidFill>
+          <a:ln/>
+        </p:spPr>
+        <p:txBody>
+          <a:bodyPr/>
+          <a:lstStyle/>
+          <a:p>
+            <a:endParaRPr lang="pt-BR"/>
+          </a:p>
+        </p:txBody>
+      </p:sp>
+      <p:sp>
+        <p:nvSpPr>
+          <p:cNvPr id="7" name="Text 4"/>
+          <p:cNvSpPr/>
+          <p:nvPr/>
+        </p:nvSpPr>
+        <p:spPr>
+          <a:xfrm>
+            <a:off x="457200" y="4800600"/>
+            <a:ext cx="6400800" cy="342900"/>
+          </a:xfrm>
+          <a:prstGeom prst="rect">
+            <a:avLst/>
+          </a:prstGeom>
+          <a:noFill/>
+          <a:ln/>
+        </p:spPr>
+        <p:txBody>
+          <a:bodyPr wrap="square" lIns="0" tIns="0" rIns="0" bIns="0" rtlCol="0" anchor="ctr"/>
+          <a:lstStyle/>
+          <a:p>
+            <a:pPr marL="0" indent="0">
+              <a:buNone/>
+            </a:pPr>
+            <a:r>
+              <a:rPr lang="en-US" sz="800" dirty="0">
+                <a:solidFill>
+                  <a:srgbClr val="FFFFFF"/>
+                </a:solidFill>
+                <a:latin typeface="Calibri" pitchFamily="34" charset="0"/>
+                <a:ea typeface="Calibri" pitchFamily="34" charset="-122"/>
+                <a:cs typeface="Calibri" pitchFamily="34" charset="-120"/>
+              </a:rPr>
+              <a:t>MCZA018 — Processamento Digital de Imagens — Q1.2026</a:t>
+            </a:r>
+            <a:endParaRPr lang="en-US" sz="800" dirty="0"/>
+          </a:p>
+        </p:txBody>
+      </p:sp>
+      <p:sp>
+        <p:nvSpPr>
+          <p:cNvPr id="8" name="Text 5"/>
+          <p:cNvSpPr/>
+          <p:nvPr/>
+        </p:nvSpPr>
+        <p:spPr>
+          <a:xfrm>
+            <a:off x="7772400" y="4800600"/>
+            <a:ext cx="914400" cy="342900"/>
+          </a:xfrm>
+          <a:prstGeom prst="rect">
+            <a:avLst/>
+          </a:prstGeom>
+          <a:noFill/>
+          <a:ln/>
+        </p:spPr>
+        <p:txBody>
+          <a:bodyPr wrap="square" lIns="0" tIns="0" rIns="0" bIns="0" rtlCol="0" anchor="ctr"/>
+          <a:lstStyle/>
+          <a:p>
+            <a:pPr marL="0" indent="0" algn="r">
+              <a:buNone/>
+            </a:pPr>
+            <a:r>
+              <a:rPr lang="en-US" sz="800" dirty="0">
+                <a:solidFill>
+                  <a:srgbClr val="FFFFFF"/>
+                </a:solidFill>
+                <a:latin typeface="Calibri" pitchFamily="34" charset="0"/>
+                <a:ea typeface="Calibri" pitchFamily="34" charset="-122"/>
+                <a:cs typeface="Calibri" pitchFamily="34" charset="-120"/>
+              </a:rPr>
+              <a:t>16/19</a:t>
+            </a:r>
+            <a:endParaRPr lang="en-US" sz="800" dirty="0"/>
+          </a:p>
+        </p:txBody>
+      </p:sp>
       <p:pic>
         <p:nvPicPr>
-          <p:cNvPr id="5" name="Image 0" descr="preencoded.png"/>
+          <p:cNvPr id="9" name="_processado">
+            <a:hlinkClick r:id="" action="ppaction://media"/>
+            <a:extLst>
+              <a:ext uri="{FF2B5EF4-FFF2-40B4-BE49-F238E27FC236}">
+                <a16:creationId xmlns:a16="http://schemas.microsoft.com/office/drawing/2014/main" id="{96546247-D975-B7FE-0B8E-75F6945B247A}"/>
+              </a:ext>
+            </a:extLst>
+          </p:cNvPr>
           <p:cNvPicPr>
             <a:picLocks noChangeAspect="1"/>
           </p:cNvPicPr>
-          <p:nvPr/>
+          <p:nvPr>
+            <a:videoFile r:link="rId2"/>
+            <p:extLst>
+              <p:ext uri="{DAA4B4D4-6D71-4841-9C94-3DE7FCFB9230}">
+                <p14:media xmlns:p14="http://schemas.microsoft.com/office/powerpoint/2010/main" r:embed="rId1"/>
+              </p:ext>
+            </p:extLst>
+          </p:nvPr>
         </p:nvPicPr>
         <p:blipFill>
-          <a:blip r:embed="rId3"/>
+          <a:blip r:embed="rId5"/>
           <a:stretch>
             <a:fillRect/>
           </a:stretch>
         </p:blipFill>
         <p:spPr>
           <a:xfrm>
-            <a:off x="4160520" y="3200400"/>
-            <a:ext cx="822960" cy="822960"/>
+            <a:off x="2573383" y="1551214"/>
+            <a:ext cx="3997234" cy="2997926"/>
           </a:xfrm>
           <a:prstGeom prst="rect">
             <a:avLst/>
           </a:prstGeom>
         </p:spPr>
       </p:pic>
-      <p:sp>
-        <p:nvSpPr>
-          <p:cNvPr id="6" name="Shape 3"/>
-          <p:cNvSpPr/>
-          <p:nvPr/>
-        </p:nvSpPr>
-        <p:spPr>
-          <a:xfrm>
-            <a:off x="0" y="4800600"/>
-            <a:ext cx="9144000" cy="342900"/>
-          </a:xfrm>
-          <a:prstGeom prst="rect">
-            <a:avLst/>
-          </a:prstGeom>
-          <a:solidFill>
-            <a:srgbClr val="003F2D"/>
-          </a:solidFill>
-          <a:ln/>
-        </p:spPr>
-        <p:txBody>
-          <a:bodyPr/>
-          <a:lstStyle/>
-          <a:p>
-            <a:endParaRPr lang="pt-BR"/>
-          </a:p>
-        </p:txBody>
-      </p:sp>
-      <p:sp>
-        <p:nvSpPr>
-          <p:cNvPr id="7" name="Text 4"/>
-          <p:cNvSpPr/>
-          <p:nvPr/>
-        </p:nvSpPr>
-        <p:spPr>
-          <a:xfrm>
-            <a:off x="457200" y="4800600"/>
-            <a:ext cx="6400800" cy="342900"/>
-          </a:xfrm>
-          <a:prstGeom prst="rect">
-            <a:avLst/>
-          </a:prstGeom>
-          <a:noFill/>
-          <a:ln/>
-        </p:spPr>
-        <p:txBody>
-          <a:bodyPr wrap="square" lIns="0" tIns="0" rIns="0" bIns="0" rtlCol="0" anchor="ctr"/>
-          <a:lstStyle/>
-          <a:p>
-            <a:pPr marL="0" indent="0">
-              <a:buNone/>
-            </a:pPr>
-            <a:r>
-              <a:rPr lang="en-US" sz="800" dirty="0">
-                <a:solidFill>
-                  <a:srgbClr val="FFFFFF"/>
-                </a:solidFill>
-                <a:latin typeface="Calibri" pitchFamily="34" charset="0"/>
-                <a:ea typeface="Calibri" pitchFamily="34" charset="-122"/>
-                <a:cs typeface="Calibri" pitchFamily="34" charset="-120"/>
-              </a:rPr>
-              <a:t>MCZA018 — Processamento Digital de Imagens — Q1.2026</a:t>
-            </a:r>
-            <a:endParaRPr lang="en-US" sz="800" dirty="0"/>
-          </a:p>
-        </p:txBody>
-      </p:sp>
-      <p:sp>
-        <p:nvSpPr>
-          <p:cNvPr id="8" name="Text 5"/>
-          <p:cNvSpPr/>
-          <p:nvPr/>
-        </p:nvSpPr>
-        <p:spPr>
-          <a:xfrm>
-            <a:off x="7772400" y="4800600"/>
-            <a:ext cx="914400" cy="342900"/>
-          </a:xfrm>
-          <a:prstGeom prst="rect">
-            <a:avLst/>
-          </a:prstGeom>
-          <a:noFill/>
-          <a:ln/>
-        </p:spPr>
-        <p:txBody>
-          <a:bodyPr wrap="square" lIns="0" tIns="0" rIns="0" bIns="0" rtlCol="0" anchor="ctr"/>
-          <a:lstStyle/>
-          <a:p>
-            <a:pPr marL="0" indent="0" algn="r">
-              <a:buNone/>
-            </a:pPr>
-            <a:r>
-              <a:rPr lang="en-US" sz="800" dirty="0">
-                <a:solidFill>
-                  <a:srgbClr val="FFFFFF"/>
-                </a:solidFill>
-                <a:latin typeface="Calibri" pitchFamily="34" charset="0"/>
-                <a:ea typeface="Calibri" pitchFamily="34" charset="-122"/>
-                <a:cs typeface="Calibri" pitchFamily="34" charset="-120"/>
-              </a:rPr>
-              <a:t>16/19</a:t>
-            </a:r>
-            <a:endParaRPr lang="en-US" sz="800" dirty="0"/>
-          </a:p>
-        </p:txBody>
-      </p:sp>
     </p:spTree>
   </p:cSld>
   <p:clrMapOvr>
     <a:masterClrMapping/>
   </p:clrMapOvr>
+  <p:timing>
+    <p:tnLst>
+      <p:par>
+        <p:cTn id="1" dur="indefinite" restart="never" nodeType="tmRoot">
+          <p:childTnLst>
+            <p:seq concurrent="1" nextAc="seek">
+              <p:cTn id="2" dur="indefinite" nodeType="mainSeq">
+                <p:childTnLst>
+                  <p:par>
+                    <p:cTn id="3" fill="hold">
+                      <p:stCondLst>
+                        <p:cond delay="indefinite"/>
+                      </p:stCondLst>
+                      <p:childTnLst>
+                        <p:par>
+                          <p:cTn id="4" fill="hold">
+                            <p:stCondLst>
+                              <p:cond delay="0"/>
+                            </p:stCondLst>
+                            <p:childTnLst>
+                              <p:par>
+                                <p:cTn id="5" presetID="1" presetClass="mediacall" presetSubtype="0" fill="hold" nodeType="clickEffect">
+                                  <p:stCondLst>
+                                    <p:cond delay="0"/>
+                                  </p:stCondLst>
+                                  <p:childTnLst>
+                                    <p:cmd type="call" cmd="playFrom(0.0)">
+                                      <p:cBhvr>
+                                        <p:cTn id="6" dur="27083" fill="hold"/>
+                                        <p:tgtEl>
+                                          <p:spTgt spid="9"/>
+                                        </p:tgtEl>
+                                      </p:cBhvr>
+                                    </p:cmd>
+                                  </p:childTnLst>
+                                </p:cTn>
+                              </p:par>
+                            </p:childTnLst>
+                          </p:cTn>
+                        </p:par>
+                      </p:childTnLst>
+                    </p:cTn>
+                  </p:par>
+                </p:childTnLst>
+              </p:cTn>
+              <p:prevCondLst>
+                <p:cond evt="onPrev" delay="0">
+                  <p:tgtEl>
+                    <p:sldTgt/>
+                  </p:tgtEl>
+                </p:cond>
+              </p:prevCondLst>
+              <p:nextCondLst>
+                <p:cond evt="onNext" delay="0">
+                  <p:tgtEl>
+                    <p:sldTgt/>
+                  </p:tgtEl>
+                </p:cond>
+              </p:nextCondLst>
+            </p:seq>
+            <p:video>
+              <p:cMediaNode vol="80000">
+                <p:cTn id="7" fill="hold" display="0">
+                  <p:stCondLst>
+                    <p:cond delay="indefinite"/>
+                  </p:stCondLst>
+                </p:cTn>
+                <p:tgtEl>
+                  <p:spTgt spid="9"/>
+                </p:tgtEl>
+              </p:cMediaNode>
+            </p:video>
+            <p:seq concurrent="1" nextAc="seek">
+              <p:cTn id="8" restart="whenNotActive" fill="hold" evtFilter="cancelBubble" nodeType="interactiveSeq">
+                <p:stCondLst>
+                  <p:cond evt="onClick" delay="0">
+                    <p:tgtEl>
+                      <p:spTgt spid="9"/>
+                    </p:tgtEl>
+                  </p:cond>
+                </p:stCondLst>
+                <p:endSync evt="end" delay="0">
+                  <p:rtn val="all"/>
+                </p:endSync>
+                <p:childTnLst>
+                  <p:par>
+                    <p:cTn id="9" fill="hold">
+                      <p:stCondLst>
+                        <p:cond delay="0"/>
+                      </p:stCondLst>
+                      <p:childTnLst>
+                        <p:par>
+                          <p:cTn id="10" fill="hold">
+                            <p:stCondLst>
+                              <p:cond delay="0"/>
+                            </p:stCondLst>
+                            <p:childTnLst>
+                              <p:par>
+                                <p:cTn id="11" presetID="2" presetClass="mediacall" presetSubtype="0" fill="hold" nodeType="clickEffect">
+                                  <p:stCondLst>
+                                    <p:cond delay="0"/>
+                                  </p:stCondLst>
+                                  <p:childTnLst>
+                                    <p:cmd type="call" cmd="togglePause">
+                                      <p:cBhvr>
+                                        <p:cTn id="12" dur="1" fill="hold"/>
+                                        <p:tgtEl>
+                                          <p:spTgt spid="9"/>
+                                        </p:tgtEl>
+                                      </p:cBhvr>
+                                    </p:cmd>
+                                  </p:childTnLst>
+                                </p:cTn>
+                              </p:par>
+                            </p:childTnLst>
+                          </p:cTn>
+                        </p:par>
+                      </p:childTnLst>
+                    </p:cTn>
+                  </p:par>
+                </p:childTnLst>
+              </p:cTn>
+              <p:nextCondLst>
+                <p:cond evt="onClick" delay="0">
+                  <p:tgtEl>
+                    <p:spTgt spid="9"/>
+                  </p:tgtEl>
+                </p:cond>
+              </p:nextCondLst>
+            </p:seq>
+          </p:childTnLst>
+        </p:cTn>
+      </p:par>
+    </p:tnLst>
+  </p:timing>
 </p:sld>
 </file>
 

</xml_diff>

<commit_message>
feat: add DogFlush presentation slide deck to project repository
</commit_message>
<xml_diff>
--- a/Projeto/DogFlush_Apresentacao.pptx
+++ b/Projeto/DogFlush_Apresentacao.pptx
@@ -5,7 +5,7 @@
     <p:sldMasterId id="2147483648" r:id="rId1"/>
   </p:sldMasterIdLst>
   <p:notesMasterIdLst>
-    <p:notesMasterId r:id="rId20"/>
+    <p:notesMasterId r:id="rId19"/>
   </p:notesMasterIdLst>
   <p:sldIdLst>
     <p:sldId id="256" r:id="rId2"/>
@@ -20,12 +20,11 @@
     <p:sldId id="265" r:id="rId11"/>
     <p:sldId id="266" r:id="rId12"/>
     <p:sldId id="267" r:id="rId13"/>
-    <p:sldId id="269" r:id="rId14"/>
-    <p:sldId id="270" r:id="rId15"/>
-    <p:sldId id="271" r:id="rId16"/>
-    <p:sldId id="272" r:id="rId17"/>
-    <p:sldId id="273" r:id="rId18"/>
-    <p:sldId id="274" r:id="rId19"/>
+    <p:sldId id="270" r:id="rId14"/>
+    <p:sldId id="271" r:id="rId15"/>
+    <p:sldId id="272" r:id="rId16"/>
+    <p:sldId id="273" r:id="rId17"/>
+    <p:sldId id="274" r:id="rId18"/>
   </p:sldIdLst>
   <p:sldSz cx="9144000" cy="5143500" type="screen16x9"/>
   <p:notesSz cx="5143500" cy="9144000"/>
@@ -1055,97 +1054,6 @@
             <a:fld id="{F7021451-1387-4CA6-816F-3879F97B5CBC}" type="slidenum">
               <a:rPr lang="en-US"/>
               <a:t>17</a:t>
-            </a:fld>
-            <a:endParaRPr lang="en-US"/>
-          </a:p>
-        </p:txBody>
-      </p:sp>
-    </p:spTree>
-    <p:extLst>
-      <p:ext uri="{BB962C8B-B14F-4D97-AF65-F5344CB8AC3E}">
-        <p14:creationId xmlns:p14="http://schemas.microsoft.com/office/powerpoint/2010/main" val="1024086991"/>
-      </p:ext>
-    </p:extLst>
-  </p:cSld>
-  <p:clrMapOvr>
-    <a:masterClrMapping/>
-  </p:clrMapOvr>
-</p:notes>
-</file>
-
-<file path=ppt/notesSlides/notesSlide18.xml><?xml version="1.0" encoding="utf-8"?>
-<p:notes xmlns:a="http://schemas.openxmlformats.org/drawingml/2006/main" xmlns:r="http://schemas.openxmlformats.org/officeDocument/2006/relationships" xmlns:p="http://schemas.openxmlformats.org/presentationml/2006/main">
-  <p:cSld>
-    <p:spTree>
-      <p:nvGrpSpPr>
-        <p:cNvPr id="1" name=""/>
-        <p:cNvGrpSpPr/>
-        <p:nvPr/>
-      </p:nvGrpSpPr>
-      <p:grpSpPr>
-        <a:xfrm>
-          <a:off x="0" y="0"/>
-          <a:ext cx="0" cy="0"/>
-          <a:chOff x="0" y="0"/>
-          <a:chExt cx="0" cy="0"/>
-        </a:xfrm>
-      </p:grpSpPr>
-      <p:sp>
-        <p:nvSpPr>
-          <p:cNvPr id="2" name="Slide Image Placeholder 1"/>
-          <p:cNvSpPr>
-            <a:spLocks noGrp="1" noRot="1" noChangeAspect="1"/>
-          </p:cNvSpPr>
-          <p:nvPr>
-            <p:ph type="sldImg"/>
-          </p:nvPr>
-        </p:nvSpPr>
-        <p:spPr/>
-        <p:txBody>
-          <a:bodyPr/>
-          <a:lstStyle/>
-          <a:p>
-            <a:endParaRPr lang="pt-BR"/>
-          </a:p>
-        </p:txBody>
-      </p:sp>
-      <p:sp>
-        <p:nvSpPr>
-          <p:cNvPr id="3" name="Notes Placeholder 2"/>
-          <p:cNvSpPr>
-            <a:spLocks noGrp="1"/>
-          </p:cNvSpPr>
-          <p:nvPr>
-            <p:ph type="body" idx="1"/>
-          </p:nvPr>
-        </p:nvSpPr>
-        <p:spPr/>
-        <p:txBody>
-          <a:bodyPr/>
-          <a:lstStyle/>
-          <a:p>
-            <a:endParaRPr lang="en-US" dirty="0"/>
-          </a:p>
-        </p:txBody>
-      </p:sp>
-      <p:sp>
-        <p:nvSpPr>
-          <p:cNvPr id="4" name="Slide Number Placeholder 3"/>
-          <p:cNvSpPr>
-            <a:spLocks noGrp="1"/>
-          </p:cNvSpPr>
-          <p:nvPr>
-            <p:ph type="sldNum" sz="quarter" idx="10"/>
-          </p:nvPr>
-        </p:nvSpPr>
-        <p:spPr/>
-        <p:txBody>
-          <a:bodyPr/>
-          <a:lstStyle/>
-          <a:p>
-            <a:fld id="{F7021451-1387-4CA6-816F-3879F97B5CBC}" type="slidenum">
-              <a:rPr lang="en-US"/>
-              <a:t>18</a:t>
             </a:fld>
             <a:endParaRPr lang="en-US"/>
           </a:p>
@@ -2573,6 +2481,36 @@
           </a:p>
         </p:txBody>
       </p:sp>
+      <p:pic>
+        <p:nvPicPr>
+          <p:cNvPr id="11" name="Imagem 10">
+            <a:extLst>
+              <a:ext uri="{FF2B5EF4-FFF2-40B4-BE49-F238E27FC236}">
+                <a16:creationId xmlns:a16="http://schemas.microsoft.com/office/drawing/2014/main" id="{2669001C-6B05-4E95-92D1-060015946E47}"/>
+              </a:ext>
+            </a:extLst>
+          </p:cNvPr>
+          <p:cNvPicPr>
+            <a:picLocks noChangeAspect="1"/>
+          </p:cNvPicPr>
+          <p:nvPr/>
+        </p:nvPicPr>
+        <p:blipFill>
+          <a:blip r:embed="rId5"/>
+          <a:stretch>
+            <a:fillRect/>
+          </a:stretch>
+        </p:blipFill>
+        <p:spPr>
+          <a:xfrm>
+            <a:off x="8354622" y="267789"/>
+            <a:ext cx="469338" cy="480060"/>
+          </a:xfrm>
+          <a:prstGeom prst="rect">
+            <a:avLst/>
+          </a:prstGeom>
+        </p:spPr>
+      </p:pic>
     </p:spTree>
   </p:cSld>
   <p:clrMapOvr>
@@ -4034,6 +3972,36 @@
           </a:p>
         </p:txBody>
       </p:sp>
+      <p:pic>
+        <p:nvPicPr>
+          <p:cNvPr id="13" name="Imagem 12">
+            <a:extLst>
+              <a:ext uri="{FF2B5EF4-FFF2-40B4-BE49-F238E27FC236}">
+                <a16:creationId xmlns:a16="http://schemas.microsoft.com/office/drawing/2014/main" id="{889FC697-C80F-96E2-4AAF-C021DFA5FAED}"/>
+              </a:ext>
+            </a:extLst>
+          </p:cNvPr>
+          <p:cNvPicPr>
+            <a:picLocks noChangeAspect="1"/>
+          </p:cNvPicPr>
+          <p:nvPr/>
+        </p:nvPicPr>
+        <p:blipFill>
+          <a:blip r:embed="rId3"/>
+          <a:stretch>
+            <a:fillRect/>
+          </a:stretch>
+        </p:blipFill>
+        <p:spPr>
+          <a:xfrm>
+            <a:off x="8354622" y="267789"/>
+            <a:ext cx="469338" cy="480060"/>
+          </a:xfrm>
+          <a:prstGeom prst="rect">
+            <a:avLst/>
+          </a:prstGeom>
+        </p:spPr>
+      </p:pic>
     </p:spTree>
   </p:cSld>
   <p:clrMapOvr>
@@ -5082,6 +5050,36 @@
           </a:p>
         </p:txBody>
       </p:sp>
+      <p:pic>
+        <p:nvPicPr>
+          <p:cNvPr id="24" name="Imagem 23">
+            <a:extLst>
+              <a:ext uri="{FF2B5EF4-FFF2-40B4-BE49-F238E27FC236}">
+                <a16:creationId xmlns:a16="http://schemas.microsoft.com/office/drawing/2014/main" id="{AF5298B7-12ED-74A4-4F03-78840BF07D95}"/>
+              </a:ext>
+            </a:extLst>
+          </p:cNvPr>
+          <p:cNvPicPr>
+            <a:picLocks noChangeAspect="1"/>
+          </p:cNvPicPr>
+          <p:nvPr/>
+        </p:nvPicPr>
+        <p:blipFill>
+          <a:blip r:embed="rId4"/>
+          <a:stretch>
+            <a:fillRect/>
+          </a:stretch>
+        </p:blipFill>
+        <p:spPr>
+          <a:xfrm>
+            <a:off x="8354622" y="267789"/>
+            <a:ext cx="469338" cy="480060"/>
+          </a:xfrm>
+          <a:prstGeom prst="rect">
+            <a:avLst/>
+          </a:prstGeom>
+        </p:spPr>
+      </p:pic>
     </p:spTree>
   </p:cSld>
   <p:clrMapOvr>
@@ -6398,6 +6396,36 @@
           </a:p>
         </p:txBody>
       </p:sp>
+      <p:pic>
+        <p:nvPicPr>
+          <p:cNvPr id="39" name="Imagem 38">
+            <a:extLst>
+              <a:ext uri="{FF2B5EF4-FFF2-40B4-BE49-F238E27FC236}">
+                <a16:creationId xmlns:a16="http://schemas.microsoft.com/office/drawing/2014/main" id="{C4062602-4BEF-C75F-1639-D2669023C6BA}"/>
+              </a:ext>
+            </a:extLst>
+          </p:cNvPr>
+          <p:cNvPicPr>
+            <a:picLocks noChangeAspect="1"/>
+          </p:cNvPicPr>
+          <p:nvPr/>
+        </p:nvPicPr>
+        <p:blipFill>
+          <a:blip r:embed="rId3"/>
+          <a:stretch>
+            <a:fillRect/>
+          </a:stretch>
+        </p:blipFill>
+        <p:spPr>
+          <a:xfrm>
+            <a:off x="8354622" y="267789"/>
+            <a:ext cx="469338" cy="480060"/>
+          </a:xfrm>
+          <a:prstGeom prst="rect">
+            <a:avLst/>
+          </a:prstGeom>
+        </p:spPr>
+      </p:pic>
     </p:spTree>
   </p:cSld>
   <p:clrMapOvr>
@@ -6407,210 +6435,6 @@
 </file>
 
 <file path=ppt/slides/slide13.xml><?xml version="1.0" encoding="utf-8"?>
-<p:sld xmlns:a="http://schemas.openxmlformats.org/drawingml/2006/main" xmlns:r="http://schemas.openxmlformats.org/officeDocument/2006/relationships" xmlns:p="http://schemas.openxmlformats.org/presentationml/2006/main">
-  <p:cSld name="Slide 14">
-    <p:bg>
-      <p:bgPr>
-        <a:solidFill>
-          <a:srgbClr val="F5F8F7"/>
-        </a:solidFill>
-        <a:effectLst/>
-      </p:bgPr>
-    </p:bg>
-    <p:spTree>
-      <p:nvGrpSpPr>
-        <p:cNvPr id="1" name=""/>
-        <p:cNvGrpSpPr/>
-        <p:nvPr/>
-      </p:nvGrpSpPr>
-      <p:grpSpPr>
-        <a:xfrm>
-          <a:off x="0" y="0"/>
-          <a:ext cx="0" cy="0"/>
-          <a:chOff x="0" y="0"/>
-          <a:chExt cx="0" cy="0"/>
-        </a:xfrm>
-      </p:grpSpPr>
-      <p:sp>
-        <p:nvSpPr>
-          <p:cNvPr id="2" name="Text 0"/>
-          <p:cNvSpPr/>
-          <p:nvPr/>
-        </p:nvSpPr>
-        <p:spPr>
-          <a:xfrm>
-            <a:off x="457200" y="228600"/>
-            <a:ext cx="8229600" cy="548640"/>
-          </a:xfrm>
-          <a:prstGeom prst="rect">
-            <a:avLst/>
-          </a:prstGeom>
-          <a:noFill/>
-          <a:ln/>
-        </p:spPr>
-        <p:txBody>
-          <a:bodyPr wrap="square" lIns="0" tIns="0" rIns="0" bIns="0" rtlCol="0" anchor="ctr"/>
-          <a:lstStyle/>
-          <a:p>
-            <a:pPr marL="0" indent="0">
-              <a:buNone/>
-            </a:pPr>
-            <a:r>
-              <a:rPr lang="en-US" sz="2600" b="1" dirty="0">
-                <a:solidFill>
-                  <a:srgbClr val="003F2D"/>
-                </a:solidFill>
-                <a:latin typeface="Arial" pitchFamily="34" charset="0"/>
-                <a:ea typeface="Arial" pitchFamily="34" charset="-122"/>
-                <a:cs typeface="Arial" pitchFamily="34" charset="-120"/>
-              </a:rPr>
-              <a:t>Métricas de Desempenho</a:t>
-            </a:r>
-            <a:endParaRPr lang="en-US" sz="2600" dirty="0"/>
-          </a:p>
-        </p:txBody>
-      </p:sp>
-      <p:sp>
-        <p:nvSpPr>
-          <p:cNvPr id="3" name="Shape 1"/>
-          <p:cNvSpPr/>
-          <p:nvPr/>
-        </p:nvSpPr>
-        <p:spPr>
-          <a:xfrm>
-            <a:off x="457200" y="804672"/>
-            <a:ext cx="1371600" cy="36576"/>
-          </a:xfrm>
-          <a:prstGeom prst="rect">
-            <a:avLst/>
-          </a:prstGeom>
-          <a:solidFill>
-            <a:srgbClr val="00897B"/>
-          </a:solidFill>
-          <a:ln/>
-        </p:spPr>
-        <p:txBody>
-          <a:bodyPr/>
-          <a:lstStyle/>
-          <a:p>
-            <a:endParaRPr lang="pt-BR"/>
-          </a:p>
-        </p:txBody>
-      </p:sp>
-      <p:sp>
-        <p:nvSpPr>
-          <p:cNvPr id="4" name="Shape 2"/>
-          <p:cNvSpPr/>
-          <p:nvPr/>
-        </p:nvSpPr>
-        <p:spPr>
-          <a:xfrm>
-            <a:off x="0" y="4800600"/>
-            <a:ext cx="9144000" cy="342900"/>
-          </a:xfrm>
-          <a:prstGeom prst="rect">
-            <a:avLst/>
-          </a:prstGeom>
-          <a:solidFill>
-            <a:srgbClr val="003F2D"/>
-          </a:solidFill>
-          <a:ln/>
-        </p:spPr>
-        <p:txBody>
-          <a:bodyPr/>
-          <a:lstStyle/>
-          <a:p>
-            <a:endParaRPr lang="pt-BR"/>
-          </a:p>
-        </p:txBody>
-      </p:sp>
-      <p:sp>
-        <p:nvSpPr>
-          <p:cNvPr id="5" name="Text 3"/>
-          <p:cNvSpPr/>
-          <p:nvPr/>
-        </p:nvSpPr>
-        <p:spPr>
-          <a:xfrm>
-            <a:off x="457200" y="4800600"/>
-            <a:ext cx="6400800" cy="342900"/>
-          </a:xfrm>
-          <a:prstGeom prst="rect">
-            <a:avLst/>
-          </a:prstGeom>
-          <a:noFill/>
-          <a:ln/>
-        </p:spPr>
-        <p:txBody>
-          <a:bodyPr wrap="square" lIns="0" tIns="0" rIns="0" bIns="0" rtlCol="0" anchor="ctr"/>
-          <a:lstStyle/>
-          <a:p>
-            <a:pPr marL="0" indent="0">
-              <a:buNone/>
-            </a:pPr>
-            <a:r>
-              <a:rPr lang="en-US" sz="800" dirty="0">
-                <a:solidFill>
-                  <a:srgbClr val="FFFFFF"/>
-                </a:solidFill>
-                <a:latin typeface="Calibri" pitchFamily="34" charset="0"/>
-                <a:ea typeface="Calibri" pitchFamily="34" charset="-122"/>
-                <a:cs typeface="Calibri" pitchFamily="34" charset="-120"/>
-              </a:rPr>
-              <a:t>MCZA018 — Processamento Digital de Imagens — Q1.2026</a:t>
-            </a:r>
-            <a:endParaRPr lang="en-US" sz="800" dirty="0"/>
-          </a:p>
-        </p:txBody>
-      </p:sp>
-      <p:sp>
-        <p:nvSpPr>
-          <p:cNvPr id="6" name="Text 4"/>
-          <p:cNvSpPr/>
-          <p:nvPr/>
-        </p:nvSpPr>
-        <p:spPr>
-          <a:xfrm>
-            <a:off x="7772400" y="4800600"/>
-            <a:ext cx="914400" cy="342900"/>
-          </a:xfrm>
-          <a:prstGeom prst="rect">
-            <a:avLst/>
-          </a:prstGeom>
-          <a:noFill/>
-          <a:ln/>
-        </p:spPr>
-        <p:txBody>
-          <a:bodyPr wrap="square" lIns="0" tIns="0" rIns="0" bIns="0" rtlCol="0" anchor="ctr"/>
-          <a:lstStyle/>
-          <a:p>
-            <a:pPr marL="0" indent="0" algn="r">
-              <a:buNone/>
-            </a:pPr>
-            <a:r>
-              <a:rPr lang="en-US" sz="800" dirty="0">
-                <a:solidFill>
-                  <a:srgbClr val="FFFFFF"/>
-                </a:solidFill>
-                <a:latin typeface="Calibri" pitchFamily="34" charset="0"/>
-                <a:ea typeface="Calibri" pitchFamily="34" charset="-122"/>
-                <a:cs typeface="Calibri" pitchFamily="34" charset="-120"/>
-              </a:rPr>
-              <a:t>14/19</a:t>
-            </a:r>
-            <a:endParaRPr lang="en-US" sz="800" dirty="0"/>
-          </a:p>
-        </p:txBody>
-      </p:sp>
-    </p:spTree>
-  </p:cSld>
-  <p:clrMapOvr>
-    <a:masterClrMapping/>
-  </p:clrMapOvr>
-</p:sld>
-</file>
-
-<file path=ppt/slides/slide14.xml><?xml version="1.0" encoding="utf-8"?>
 <p:sld xmlns:a="http://schemas.openxmlformats.org/drawingml/2006/main" xmlns:r="http://schemas.openxmlformats.org/officeDocument/2006/relationships" xmlns:p="http://schemas.openxmlformats.org/presentationml/2006/main">
   <p:cSld name="Slide 15">
     <p:bg>
@@ -6815,7 +6639,7 @@
         <p:spPr>
           <a:xfrm>
             <a:off x="457200" y="1051560"/>
-            <a:ext cx="1920240" cy="2560320"/>
+            <a:ext cx="1920240" cy="1809206"/>
           </a:xfrm>
           <a:prstGeom prst="rect">
             <a:avLst/>
@@ -6849,7 +6673,7 @@
         <p:spPr>
           <a:xfrm>
             <a:off x="1143000" y="1188720"/>
-            <a:ext cx="548640" cy="548640"/>
+            <a:ext cx="548640" cy="387687"/>
           </a:xfrm>
           <a:prstGeom prst="line">
             <a:avLst/>
@@ -6869,53 +6693,14 @@
       </p:sp>
       <p:sp>
         <p:nvSpPr>
-          <p:cNvPr id="9" name="Text 7"/>
-          <p:cNvSpPr/>
-          <p:nvPr/>
-        </p:nvSpPr>
-        <p:spPr>
-          <a:xfrm>
-            <a:off x="1143000" y="1188720"/>
-            <a:ext cx="548640" cy="548640"/>
-          </a:xfrm>
-          <a:prstGeom prst="rect">
-            <a:avLst/>
-          </a:prstGeom>
-          <a:noFill/>
-          <a:ln/>
-        </p:spPr>
-        <p:txBody>
-          <a:bodyPr wrap="square" lIns="0" tIns="0" rIns="0" bIns="0" rtlCol="0" anchor="ctr"/>
-          <a:lstStyle/>
-          <a:p>
-            <a:pPr marL="0" indent="0" algn="ctr">
-              <a:buNone/>
-            </a:pPr>
-            <a:r>
-              <a:rPr lang="en-US" sz="2200" b="1" dirty="0">
-                <a:solidFill>
-                  <a:srgbClr val="FFFFFF"/>
-                </a:solidFill>
-                <a:latin typeface="Arial Black" pitchFamily="34" charset="0"/>
-                <a:ea typeface="Arial Black" pitchFamily="34" charset="-122"/>
-                <a:cs typeface="Arial Black" pitchFamily="34" charset="-120"/>
-              </a:rPr>
-              <a:t>1</a:t>
-            </a:r>
-            <a:endParaRPr lang="en-US" sz="2200" dirty="0"/>
-          </a:p>
-        </p:txBody>
-      </p:sp>
-      <p:sp>
-        <p:nvSpPr>
           <p:cNvPr id="10" name="Text 8"/>
           <p:cNvSpPr/>
           <p:nvPr/>
         </p:nvSpPr>
         <p:spPr>
           <a:xfrm>
-            <a:off x="594360" y="1874520"/>
-            <a:ext cx="1645920" cy="320040"/>
+            <a:off x="594360" y="1384665"/>
+            <a:ext cx="1645920" cy="226151"/>
           </a:xfrm>
           <a:prstGeom prst="rect">
             <a:avLst/>
@@ -6953,8 +6738,8 @@
         </p:nvSpPr>
         <p:spPr>
           <a:xfrm>
-            <a:off x="594360" y="2240280"/>
-            <a:ext cx="1645920" cy="1188720"/>
+            <a:off x="594360" y="1750425"/>
+            <a:ext cx="1645920" cy="839989"/>
           </a:xfrm>
           <a:prstGeom prst="rect">
             <a:avLst/>
@@ -6996,7 +6781,7 @@
         <p:spPr>
           <a:xfrm>
             <a:off x="2606040" y="1051560"/>
-            <a:ext cx="1920240" cy="2560320"/>
+            <a:ext cx="1920240" cy="1809206"/>
           </a:xfrm>
           <a:prstGeom prst="rect">
             <a:avLst/>
@@ -7030,7 +6815,7 @@
         <p:spPr>
           <a:xfrm>
             <a:off x="3291840" y="1188720"/>
-            <a:ext cx="548640" cy="548640"/>
+            <a:ext cx="548640" cy="387687"/>
           </a:xfrm>
           <a:prstGeom prst="line">
             <a:avLst/>
@@ -7050,53 +6835,14 @@
       </p:sp>
       <p:sp>
         <p:nvSpPr>
-          <p:cNvPr id="14" name="Text 12"/>
-          <p:cNvSpPr/>
-          <p:nvPr/>
-        </p:nvSpPr>
-        <p:spPr>
-          <a:xfrm>
-            <a:off x="3291840" y="1188720"/>
-            <a:ext cx="548640" cy="548640"/>
-          </a:xfrm>
-          <a:prstGeom prst="rect">
-            <a:avLst/>
-          </a:prstGeom>
-          <a:noFill/>
-          <a:ln/>
-        </p:spPr>
-        <p:txBody>
-          <a:bodyPr wrap="square" lIns="0" tIns="0" rIns="0" bIns="0" rtlCol="0" anchor="ctr"/>
-          <a:lstStyle/>
-          <a:p>
-            <a:pPr marL="0" indent="0" algn="ctr">
-              <a:buNone/>
-            </a:pPr>
-            <a:r>
-              <a:rPr lang="en-US" sz="2200" b="1" dirty="0">
-                <a:solidFill>
-                  <a:srgbClr val="FFFFFF"/>
-                </a:solidFill>
-                <a:latin typeface="Arial Black" pitchFamily="34" charset="0"/>
-                <a:ea typeface="Arial Black" pitchFamily="34" charset="-122"/>
-                <a:cs typeface="Arial Black" pitchFamily="34" charset="-120"/>
-              </a:rPr>
-              <a:t>2</a:t>
-            </a:r>
-            <a:endParaRPr lang="en-US" sz="2200" dirty="0"/>
-          </a:p>
-        </p:txBody>
-      </p:sp>
-      <p:sp>
-        <p:nvSpPr>
           <p:cNvPr id="15" name="Text 13"/>
           <p:cNvSpPr/>
           <p:nvPr/>
         </p:nvSpPr>
         <p:spPr>
           <a:xfrm>
-            <a:off x="2743200" y="1874520"/>
-            <a:ext cx="1645920" cy="320040"/>
+            <a:off x="2743200" y="1384665"/>
+            <a:ext cx="1645920" cy="226151"/>
           </a:xfrm>
           <a:prstGeom prst="rect">
             <a:avLst/>
@@ -7134,8 +6880,8 @@
         </p:nvSpPr>
         <p:spPr>
           <a:xfrm>
-            <a:off x="2743200" y="2240280"/>
-            <a:ext cx="1645920" cy="1188720"/>
+            <a:off x="2743200" y="1750425"/>
+            <a:ext cx="1645920" cy="839989"/>
           </a:xfrm>
           <a:prstGeom prst="rect">
             <a:avLst/>
@@ -7177,7 +6923,7 @@
         <p:spPr>
           <a:xfrm>
             <a:off x="4754880" y="1051560"/>
-            <a:ext cx="1920240" cy="2560320"/>
+            <a:ext cx="1920240" cy="1809206"/>
           </a:xfrm>
           <a:prstGeom prst="rect">
             <a:avLst/>
@@ -7211,7 +6957,7 @@
         <p:spPr>
           <a:xfrm>
             <a:off x="5440680" y="1188720"/>
-            <a:ext cx="548640" cy="548640"/>
+            <a:ext cx="548640" cy="387687"/>
           </a:xfrm>
           <a:prstGeom prst="line">
             <a:avLst/>
@@ -7231,53 +6977,14 @@
       </p:sp>
       <p:sp>
         <p:nvSpPr>
-          <p:cNvPr id="19" name="Text 17"/>
-          <p:cNvSpPr/>
-          <p:nvPr/>
-        </p:nvSpPr>
-        <p:spPr>
-          <a:xfrm>
-            <a:off x="5440680" y="1188720"/>
-            <a:ext cx="548640" cy="548640"/>
-          </a:xfrm>
-          <a:prstGeom prst="rect">
-            <a:avLst/>
-          </a:prstGeom>
-          <a:noFill/>
-          <a:ln/>
-        </p:spPr>
-        <p:txBody>
-          <a:bodyPr wrap="square" lIns="0" tIns="0" rIns="0" bIns="0" rtlCol="0" anchor="ctr"/>
-          <a:lstStyle/>
-          <a:p>
-            <a:pPr marL="0" indent="0" algn="ctr">
-              <a:buNone/>
-            </a:pPr>
-            <a:r>
-              <a:rPr lang="en-US" sz="2200" b="1" dirty="0">
-                <a:solidFill>
-                  <a:srgbClr val="FFFFFF"/>
-                </a:solidFill>
-                <a:latin typeface="Arial Black" pitchFamily="34" charset="0"/>
-                <a:ea typeface="Arial Black" pitchFamily="34" charset="-122"/>
-                <a:cs typeface="Arial Black" pitchFamily="34" charset="-120"/>
-              </a:rPr>
-              <a:t>3</a:t>
-            </a:r>
-            <a:endParaRPr lang="en-US" sz="2200" dirty="0"/>
-          </a:p>
-        </p:txBody>
-      </p:sp>
-      <p:sp>
-        <p:nvSpPr>
           <p:cNvPr id="20" name="Text 18"/>
           <p:cNvSpPr/>
           <p:nvPr/>
         </p:nvSpPr>
         <p:spPr>
           <a:xfrm>
-            <a:off x="4892040" y="1874520"/>
-            <a:ext cx="1645920" cy="320040"/>
+            <a:off x="4892040" y="1384665"/>
+            <a:ext cx="1645920" cy="226151"/>
           </a:xfrm>
           <a:prstGeom prst="rect">
             <a:avLst/>
@@ -7315,8 +7022,8 @@
         </p:nvSpPr>
         <p:spPr>
           <a:xfrm>
-            <a:off x="4892040" y="2240280"/>
-            <a:ext cx="1645920" cy="1188720"/>
+            <a:off x="4892040" y="1750425"/>
+            <a:ext cx="1645920" cy="839989"/>
           </a:xfrm>
           <a:prstGeom prst="rect">
             <a:avLst/>
@@ -7358,7 +7065,7 @@
         <p:spPr>
           <a:xfrm>
             <a:off x="6903720" y="1051560"/>
-            <a:ext cx="1920240" cy="2560320"/>
+            <a:ext cx="1920240" cy="1809206"/>
           </a:xfrm>
           <a:prstGeom prst="rect">
             <a:avLst/>
@@ -7392,7 +7099,7 @@
         <p:spPr>
           <a:xfrm>
             <a:off x="7589520" y="1188720"/>
-            <a:ext cx="548640" cy="548640"/>
+            <a:ext cx="548640" cy="387687"/>
           </a:xfrm>
           <a:prstGeom prst="line">
             <a:avLst/>
@@ -7412,53 +7119,14 @@
       </p:sp>
       <p:sp>
         <p:nvSpPr>
-          <p:cNvPr id="24" name="Text 22"/>
-          <p:cNvSpPr/>
-          <p:nvPr/>
-        </p:nvSpPr>
-        <p:spPr>
-          <a:xfrm>
-            <a:off x="7589520" y="1188720"/>
-            <a:ext cx="548640" cy="548640"/>
-          </a:xfrm>
-          <a:prstGeom prst="rect">
-            <a:avLst/>
-          </a:prstGeom>
-          <a:noFill/>
-          <a:ln/>
-        </p:spPr>
-        <p:txBody>
-          <a:bodyPr wrap="square" lIns="0" tIns="0" rIns="0" bIns="0" rtlCol="0" anchor="ctr"/>
-          <a:lstStyle/>
-          <a:p>
-            <a:pPr marL="0" indent="0" algn="ctr">
-              <a:buNone/>
-            </a:pPr>
-            <a:r>
-              <a:rPr lang="en-US" sz="2200" b="1" dirty="0">
-                <a:solidFill>
-                  <a:srgbClr val="FFFFFF"/>
-                </a:solidFill>
-                <a:latin typeface="Arial Black" pitchFamily="34" charset="0"/>
-                <a:ea typeface="Arial Black" pitchFamily="34" charset="-122"/>
-                <a:cs typeface="Arial Black" pitchFamily="34" charset="-120"/>
-              </a:rPr>
-              <a:t>4</a:t>
-            </a:r>
-            <a:endParaRPr lang="en-US" sz="2200" dirty="0"/>
-          </a:p>
-        </p:txBody>
-      </p:sp>
-      <p:sp>
-        <p:nvSpPr>
           <p:cNvPr id="25" name="Text 23"/>
           <p:cNvSpPr/>
           <p:nvPr/>
         </p:nvSpPr>
         <p:spPr>
           <a:xfrm>
-            <a:off x="7040880" y="1874520"/>
-            <a:ext cx="1645920" cy="320040"/>
+            <a:off x="7040880" y="1384665"/>
+            <a:ext cx="1645920" cy="226151"/>
           </a:xfrm>
           <a:prstGeom prst="rect">
             <a:avLst/>
@@ -7496,8 +7164,8 @@
         </p:nvSpPr>
         <p:spPr>
           <a:xfrm>
-            <a:off x="7040880" y="2240280"/>
-            <a:ext cx="1645920" cy="1188720"/>
+            <a:off x="7040880" y="1750425"/>
+            <a:ext cx="1645920" cy="839989"/>
           </a:xfrm>
           <a:prstGeom prst="rect">
             <a:avLst/>
@@ -7538,8 +7206,8 @@
         </p:nvSpPr>
         <p:spPr>
           <a:xfrm>
-            <a:off x="457200" y="3840480"/>
-            <a:ext cx="8229600" cy="640080"/>
+            <a:off x="457200" y="3135086"/>
+            <a:ext cx="8229600" cy="1395162"/>
           </a:xfrm>
           <a:prstGeom prst="rect">
             <a:avLst/>
@@ -7553,7 +7221,7 @@
           <a:bodyPr/>
           <a:lstStyle/>
           <a:p>
-            <a:endParaRPr lang="pt-BR"/>
+            <a:endParaRPr lang="pt-BR" dirty="0"/>
           </a:p>
         </p:txBody>
       </p:sp>
@@ -7565,7 +7233,7 @@
         </p:nvSpPr>
         <p:spPr>
           <a:xfrm>
-            <a:off x="685800" y="3840480"/>
+            <a:off x="685800" y="3520440"/>
             <a:ext cx="7772400" cy="640080"/>
           </a:xfrm>
           <a:prstGeom prst="rect">
@@ -7578,35 +7246,176 @@
           <a:bodyPr wrap="square" lIns="0" tIns="0" rIns="0" bIns="0" rtlCol="0" anchor="ctr"/>
           <a:lstStyle/>
           <a:p>
-            <a:pPr marL="0" indent="0">
-              <a:buNone/>
-            </a:pPr>
-            <a:r>
-              <a:rPr lang="en-US" sz="1200" b="1" dirty="0" err="1">
-                <a:solidFill>
-                  <a:srgbClr val="003F2D"/>
-                </a:solidFill>
-                <a:latin typeface="Calibri" pitchFamily="34" charset="0"/>
-                <a:ea typeface="Calibri" pitchFamily="34" charset="-122"/>
-                <a:cs typeface="Calibri" pitchFamily="34" charset="-120"/>
-              </a:rPr>
+            <a:r>
+              <a:rPr sz="1400" dirty="0" err="1"/>
+              <a:t>Resultados</a:t>
+            </a:r>
+            <a:r>
+              <a:rPr sz="1400" dirty="0"/>
+              <a:t> da </a:t>
+            </a:r>
+            <a:r>
+              <a:rPr sz="1400" dirty="0" err="1"/>
               <a:t>Avaliação</a:t>
             </a:r>
             <a:r>
-              <a:rPr lang="en-US" sz="1200" b="1" dirty="0">
-                <a:solidFill>
-                  <a:srgbClr val="003F2D"/>
-                </a:solidFill>
-                <a:latin typeface="Calibri" pitchFamily="34" charset="0"/>
-                <a:ea typeface="Calibri" pitchFamily="34" charset="-122"/>
-                <a:cs typeface="Calibri" pitchFamily="34" charset="-120"/>
-              </a:rPr>
-              <a:t>: ADICIOJNAR RESULTADOS DOS FORMULARTIOs</a:t>
-            </a:r>
-            <a:endParaRPr lang="en-US" sz="1200" dirty="0"/>
-          </a:p>
-        </p:txBody>
-      </p:sp>
+              <a:rPr sz="1400" dirty="0"/>
+              <a:t> </a:t>
+            </a:r>
+            <a:r>
+              <a:rPr sz="1400" dirty="0" err="1"/>
+              <a:t>Subjetiva</a:t>
+            </a:r>
+            <a:r>
+              <a:rPr lang="en-US" sz="1400" dirty="0"/>
+              <a:t>:</a:t>
+            </a:r>
+            <a:endParaRPr sz="1400" dirty="0"/>
+          </a:p>
+          <a:p>
+            <a:r>
+              <a:rPr sz="1400" dirty="0"/>
+              <a:t>• </a:t>
+            </a:r>
+            <a:r>
+              <a:rPr sz="1400" dirty="0" err="1"/>
+              <a:t>Fácil</a:t>
+            </a:r>
+            <a:r>
+              <a:rPr sz="1400" dirty="0"/>
+              <a:t> de usar, </a:t>
+            </a:r>
+            <a:r>
+              <a:rPr sz="1400" dirty="0" err="1"/>
+              <a:t>aprender</a:t>
+            </a:r>
+            <a:r>
+              <a:rPr sz="1400" dirty="0"/>
+              <a:t> e </a:t>
+            </a:r>
+            <a:r>
+              <a:rPr sz="1400" dirty="0" err="1"/>
+              <a:t>interativo</a:t>
+            </a:r>
+            <a:r>
+              <a:rPr sz="1400" dirty="0"/>
+              <a:t>: Nota 5.0/5.0</a:t>
+            </a:r>
+          </a:p>
+          <a:p>
+            <a:r>
+              <a:rPr sz="1400" dirty="0"/>
+              <a:t>• </a:t>
+            </a:r>
+            <a:r>
+              <a:rPr sz="1400" dirty="0" err="1"/>
+              <a:t>Confiança</a:t>
+            </a:r>
+            <a:r>
+              <a:rPr sz="1400" dirty="0"/>
+              <a:t> e </a:t>
+            </a:r>
+            <a:r>
+              <a:rPr sz="1400" dirty="0" err="1"/>
+              <a:t>intenção</a:t>
+            </a:r>
+            <a:r>
+              <a:rPr sz="1400" dirty="0"/>
+              <a:t> de </a:t>
+            </a:r>
+            <a:r>
+              <a:rPr sz="1400" dirty="0" err="1"/>
+              <a:t>uso</a:t>
+            </a:r>
+            <a:r>
+              <a:rPr sz="1400" dirty="0"/>
+              <a:t>: Nota 4.8/5.0</a:t>
+            </a:r>
+          </a:p>
+          <a:p>
+            <a:r>
+              <a:rPr sz="1400" dirty="0"/>
+              <a:t>• Feedback: Timers </a:t>
+            </a:r>
+            <a:r>
+              <a:rPr sz="1400" dirty="0" err="1"/>
+              <a:t>precisos</a:t>
+            </a:r>
+            <a:r>
+              <a:rPr sz="1400" dirty="0"/>
+              <a:t> e HUD </a:t>
+            </a:r>
+            <a:r>
+              <a:rPr sz="1400" dirty="0" err="1"/>
+              <a:t>intuitivo</a:t>
+            </a:r>
+            <a:r>
+              <a:rPr sz="1400" dirty="0"/>
+              <a:t>.</a:t>
+            </a:r>
+          </a:p>
+          <a:p>
+            <a:r>
+              <a:rPr sz="1400" dirty="0"/>
+              <a:t>• </a:t>
+            </a:r>
+            <a:r>
+              <a:rPr sz="1400" dirty="0" err="1"/>
+              <a:t>Sugestão</a:t>
+            </a:r>
+            <a:r>
+              <a:rPr sz="1400" dirty="0"/>
+              <a:t>: </a:t>
+            </a:r>
+            <a:r>
+              <a:rPr sz="1400" dirty="0" err="1"/>
+              <a:t>Integração</a:t>
+            </a:r>
+            <a:r>
+              <a:rPr sz="1400" dirty="0"/>
+              <a:t> com IA para </a:t>
+            </a:r>
+            <a:r>
+              <a:rPr sz="1400" dirty="0" err="1"/>
+              <a:t>identificar</a:t>
+            </a:r>
+            <a:r>
+              <a:rPr sz="1400" dirty="0"/>
+              <a:t> o pet.</a:t>
+            </a:r>
+          </a:p>
+        </p:txBody>
+      </p:sp>
+      <p:pic>
+        <p:nvPicPr>
+          <p:cNvPr id="30" name="Imagem 29">
+            <a:extLst>
+              <a:ext uri="{FF2B5EF4-FFF2-40B4-BE49-F238E27FC236}">
+                <a16:creationId xmlns:a16="http://schemas.microsoft.com/office/drawing/2014/main" id="{536FEC0B-8C16-1B2D-633E-CFD3F01ADB22}"/>
+              </a:ext>
+            </a:extLst>
+          </p:cNvPr>
+          <p:cNvPicPr>
+            <a:picLocks noChangeAspect="1"/>
+          </p:cNvPicPr>
+          <p:nvPr/>
+        </p:nvPicPr>
+        <p:blipFill>
+          <a:blip r:embed="rId3"/>
+          <a:stretch>
+            <a:fillRect/>
+          </a:stretch>
+        </p:blipFill>
+        <p:spPr>
+          <a:xfrm>
+            <a:off x="8354622" y="267789"/>
+            <a:ext cx="469338" cy="480060"/>
+          </a:xfrm>
+          <a:prstGeom prst="rect">
+            <a:avLst/>
+          </a:prstGeom>
+        </p:spPr>
+      </p:pic>
     </p:spTree>
   </p:cSld>
   <p:clrMapOvr>
@@ -7615,7 +7424,7 @@
 </p:sld>
 </file>
 
-<file path=ppt/slides/slide15.xml><?xml version="1.0" encoding="utf-8"?>
+<file path=ppt/slides/slide14.xml><?xml version="1.0" encoding="utf-8"?>
 <p:sld xmlns:a="http://schemas.openxmlformats.org/drawingml/2006/main" xmlns:r="http://schemas.openxmlformats.org/officeDocument/2006/relationships" xmlns:p="http://schemas.openxmlformats.org/presentationml/2006/main">
   <p:cSld name="Slide 16">
     <p:bg>
@@ -7845,6 +7654,36 @@
           <a:xfrm>
             <a:off x="2573383" y="1551214"/>
             <a:ext cx="3997234" cy="2997926"/>
+          </a:xfrm>
+          <a:prstGeom prst="rect">
+            <a:avLst/>
+          </a:prstGeom>
+        </p:spPr>
+      </p:pic>
+      <p:pic>
+        <p:nvPicPr>
+          <p:cNvPr id="3" name="Imagem 2">
+            <a:extLst>
+              <a:ext uri="{FF2B5EF4-FFF2-40B4-BE49-F238E27FC236}">
+                <a16:creationId xmlns:a16="http://schemas.microsoft.com/office/drawing/2014/main" id="{8C45F83C-6AD5-C053-EB65-F2FB0AC89320}"/>
+              </a:ext>
+            </a:extLst>
+          </p:cNvPr>
+          <p:cNvPicPr>
+            <a:picLocks noChangeAspect="1"/>
+          </p:cNvPicPr>
+          <p:nvPr/>
+        </p:nvPicPr>
+        <p:blipFill>
+          <a:blip r:embed="rId6"/>
+          <a:stretch>
+            <a:fillRect/>
+          </a:stretch>
+        </p:blipFill>
+        <p:spPr>
+          <a:xfrm>
+            <a:off x="8354622" y="267789"/>
+            <a:ext cx="469338" cy="480060"/>
           </a:xfrm>
           <a:prstGeom prst="rect">
             <a:avLst/>
@@ -7994,7 +7833,7 @@
 </p:sld>
 </file>
 
-<file path=ppt/slides/slide16.xml><?xml version="1.0" encoding="utf-8"?>
+<file path=ppt/slides/slide15.xml><?xml version="1.0" encoding="utf-8"?>
 <p:sld xmlns:a="http://schemas.openxmlformats.org/drawingml/2006/main" xmlns:r="http://schemas.openxmlformats.org/officeDocument/2006/relationships" xmlns:p="http://schemas.openxmlformats.org/presentationml/2006/main">
   <p:cSld name="Slide 17">
     <p:bg>
@@ -8816,6 +8655,36 @@
           </a:p>
         </p:txBody>
       </p:sp>
+      <p:pic>
+        <p:nvPicPr>
+          <p:cNvPr id="15" name="Imagem 14">
+            <a:extLst>
+              <a:ext uri="{FF2B5EF4-FFF2-40B4-BE49-F238E27FC236}">
+                <a16:creationId xmlns:a16="http://schemas.microsoft.com/office/drawing/2014/main" id="{16246698-6C35-0215-9B18-50C8B833177E}"/>
+              </a:ext>
+            </a:extLst>
+          </p:cNvPr>
+          <p:cNvPicPr>
+            <a:picLocks noChangeAspect="1"/>
+          </p:cNvPicPr>
+          <p:nvPr/>
+        </p:nvPicPr>
+        <p:blipFill>
+          <a:blip r:embed="rId3"/>
+          <a:stretch>
+            <a:fillRect/>
+          </a:stretch>
+        </p:blipFill>
+        <p:spPr>
+          <a:xfrm>
+            <a:off x="8354622" y="267789"/>
+            <a:ext cx="469338" cy="480060"/>
+          </a:xfrm>
+          <a:prstGeom prst="rect">
+            <a:avLst/>
+          </a:prstGeom>
+        </p:spPr>
+      </p:pic>
     </p:spTree>
   </p:cSld>
   <p:clrMapOvr>
@@ -8824,7 +8693,7 @@
 </p:sld>
 </file>
 
-<file path=ppt/slides/slide17.xml><?xml version="1.0" encoding="utf-8"?>
+<file path=ppt/slides/slide16.xml><?xml version="1.0" encoding="utf-8"?>
 <p:sld xmlns:a="http://schemas.openxmlformats.org/drawingml/2006/main" xmlns:r="http://schemas.openxmlformats.org/officeDocument/2006/relationships" xmlns:p="http://schemas.openxmlformats.org/presentationml/2006/main">
   <p:cSld name="Slide 18">
     <p:bg>
@@ -9231,6 +9100,36 @@
           </a:p>
         </p:txBody>
       </p:sp>
+      <p:pic>
+        <p:nvPicPr>
+          <p:cNvPr id="9" name="Imagem 8">
+            <a:extLst>
+              <a:ext uri="{FF2B5EF4-FFF2-40B4-BE49-F238E27FC236}">
+                <a16:creationId xmlns:a16="http://schemas.microsoft.com/office/drawing/2014/main" id="{53639E38-F72C-BF8C-76DB-DFE68E894F6D}"/>
+              </a:ext>
+            </a:extLst>
+          </p:cNvPr>
+          <p:cNvPicPr>
+            <a:picLocks noChangeAspect="1"/>
+          </p:cNvPicPr>
+          <p:nvPr/>
+        </p:nvPicPr>
+        <p:blipFill>
+          <a:blip r:embed="rId3"/>
+          <a:stretch>
+            <a:fillRect/>
+          </a:stretch>
+        </p:blipFill>
+        <p:spPr>
+          <a:xfrm>
+            <a:off x="8354622" y="267789"/>
+            <a:ext cx="469338" cy="480060"/>
+          </a:xfrm>
+          <a:prstGeom prst="rect">
+            <a:avLst/>
+          </a:prstGeom>
+        </p:spPr>
+      </p:pic>
     </p:spTree>
   </p:cSld>
   <p:clrMapOvr>
@@ -9239,7 +9138,7 @@
 </p:sld>
 </file>
 
-<file path=ppt/slides/slide18.xml><?xml version="1.0" encoding="utf-8"?>
+<file path=ppt/slides/slide17.xml><?xml version="1.0" encoding="utf-8"?>
 <p:sld xmlns:a="http://schemas.openxmlformats.org/drawingml/2006/main" xmlns:r="http://schemas.openxmlformats.org/officeDocument/2006/relationships" xmlns:p="http://schemas.openxmlformats.org/presentationml/2006/main">
   <p:cSld name="Slide 19">
     <p:bg>
@@ -9680,6 +9579,36 @@
           </a:p>
         </p:txBody>
       </p:sp>
+      <p:pic>
+        <p:nvPicPr>
+          <p:cNvPr id="8" name="Imagem 7">
+            <a:extLst>
+              <a:ext uri="{FF2B5EF4-FFF2-40B4-BE49-F238E27FC236}">
+                <a16:creationId xmlns:a16="http://schemas.microsoft.com/office/drawing/2014/main" id="{61201ACC-49A1-36B8-7EFD-C20A33BA4016}"/>
+              </a:ext>
+            </a:extLst>
+          </p:cNvPr>
+          <p:cNvPicPr>
+            <a:picLocks noChangeAspect="1"/>
+          </p:cNvPicPr>
+          <p:nvPr/>
+        </p:nvPicPr>
+        <p:blipFill>
+          <a:blip r:embed="rId3"/>
+          <a:stretch>
+            <a:fillRect/>
+          </a:stretch>
+        </p:blipFill>
+        <p:spPr>
+          <a:xfrm>
+            <a:off x="8354622" y="267789"/>
+            <a:ext cx="469338" cy="480060"/>
+          </a:xfrm>
+          <a:prstGeom prst="rect">
+            <a:avLst/>
+          </a:prstGeom>
+        </p:spPr>
+      </p:pic>
     </p:spTree>
   </p:cSld>
   <p:clrMapOvr>
@@ -10934,6 +10863,36 @@
           </a:p>
         </p:txBody>
       </p:sp>
+      <p:pic>
+        <p:nvPicPr>
+          <p:cNvPr id="37" name="Imagem 36">
+            <a:extLst>
+              <a:ext uri="{FF2B5EF4-FFF2-40B4-BE49-F238E27FC236}">
+                <a16:creationId xmlns:a16="http://schemas.microsoft.com/office/drawing/2014/main" id="{D5793FA9-2DDC-07D7-33B8-406ACF7BE3BC}"/>
+              </a:ext>
+            </a:extLst>
+          </p:cNvPr>
+          <p:cNvPicPr>
+            <a:picLocks noChangeAspect="1"/>
+          </p:cNvPicPr>
+          <p:nvPr/>
+        </p:nvPicPr>
+        <p:blipFill>
+          <a:blip r:embed="rId3"/>
+          <a:stretch>
+            <a:fillRect/>
+          </a:stretch>
+        </p:blipFill>
+        <p:spPr>
+          <a:xfrm>
+            <a:off x="8354622" y="267789"/>
+            <a:ext cx="469338" cy="480060"/>
+          </a:xfrm>
+          <a:prstGeom prst="rect">
+            <a:avLst/>
+          </a:prstGeom>
+        </p:spPr>
+      </p:pic>
     </p:spTree>
   </p:cSld>
   <p:clrMapOvr>
@@ -11596,6 +11555,36 @@
           </a:p>
         </p:txBody>
       </p:sp>
+      <p:pic>
+        <p:nvPicPr>
+          <p:cNvPr id="15" name="Imagem 14">
+            <a:extLst>
+              <a:ext uri="{FF2B5EF4-FFF2-40B4-BE49-F238E27FC236}">
+                <a16:creationId xmlns:a16="http://schemas.microsoft.com/office/drawing/2014/main" id="{375B9F4C-87F9-6B69-1A93-D085D5A76654}"/>
+              </a:ext>
+            </a:extLst>
+          </p:cNvPr>
+          <p:cNvPicPr>
+            <a:picLocks noChangeAspect="1"/>
+          </p:cNvPicPr>
+          <p:nvPr/>
+        </p:nvPicPr>
+        <p:blipFill>
+          <a:blip r:embed="rId3"/>
+          <a:stretch>
+            <a:fillRect/>
+          </a:stretch>
+        </p:blipFill>
+        <p:spPr>
+          <a:xfrm>
+            <a:off x="8354622" y="267789"/>
+            <a:ext cx="469338" cy="480060"/>
+          </a:xfrm>
+          <a:prstGeom prst="rect">
+            <a:avLst/>
+          </a:prstGeom>
+        </p:spPr>
+      </p:pic>
     </p:spTree>
   </p:cSld>
   <p:clrMapOvr>
@@ -12337,6 +12326,36 @@
           </a:p>
         </p:txBody>
       </p:sp>
+      <p:pic>
+        <p:nvPicPr>
+          <p:cNvPr id="23" name="Imagem 22">
+            <a:extLst>
+              <a:ext uri="{FF2B5EF4-FFF2-40B4-BE49-F238E27FC236}">
+                <a16:creationId xmlns:a16="http://schemas.microsoft.com/office/drawing/2014/main" id="{EF486628-763D-60FB-17FC-6B44DB84C171}"/>
+              </a:ext>
+            </a:extLst>
+          </p:cNvPr>
+          <p:cNvPicPr>
+            <a:picLocks noChangeAspect="1"/>
+          </p:cNvPicPr>
+          <p:nvPr/>
+        </p:nvPicPr>
+        <p:blipFill>
+          <a:blip r:embed="rId6"/>
+          <a:stretch>
+            <a:fillRect/>
+          </a:stretch>
+        </p:blipFill>
+        <p:spPr>
+          <a:xfrm>
+            <a:off x="8354622" y="267789"/>
+            <a:ext cx="469338" cy="480060"/>
+          </a:xfrm>
+          <a:prstGeom prst="rect">
+            <a:avLst/>
+          </a:prstGeom>
+        </p:spPr>
+      </p:pic>
     </p:spTree>
   </p:cSld>
   <p:clrMapOvr>
@@ -13592,6 +13611,36 @@
           </a:p>
         </p:txBody>
       </p:sp>
+      <p:pic>
+        <p:nvPicPr>
+          <p:cNvPr id="37" name="Imagem 36">
+            <a:extLst>
+              <a:ext uri="{FF2B5EF4-FFF2-40B4-BE49-F238E27FC236}">
+                <a16:creationId xmlns:a16="http://schemas.microsoft.com/office/drawing/2014/main" id="{D81290F5-83A9-649F-148E-A03493A626E9}"/>
+              </a:ext>
+            </a:extLst>
+          </p:cNvPr>
+          <p:cNvPicPr>
+            <a:picLocks noChangeAspect="1"/>
+          </p:cNvPicPr>
+          <p:nvPr/>
+        </p:nvPicPr>
+        <p:blipFill>
+          <a:blip r:embed="rId11"/>
+          <a:stretch>
+            <a:fillRect/>
+          </a:stretch>
+        </p:blipFill>
+        <p:spPr>
+          <a:xfrm>
+            <a:off x="8354622" y="267789"/>
+            <a:ext cx="469338" cy="480060"/>
+          </a:xfrm>
+          <a:prstGeom prst="rect">
+            <a:avLst/>
+          </a:prstGeom>
+        </p:spPr>
+      </p:pic>
     </p:spTree>
   </p:cSld>
   <p:clrMapOvr>
@@ -14314,6 +14363,36 @@
           </a:p>
         </p:txBody>
       </p:sp>
+      <p:pic>
+        <p:nvPicPr>
+          <p:cNvPr id="17" name="Imagem 16">
+            <a:extLst>
+              <a:ext uri="{FF2B5EF4-FFF2-40B4-BE49-F238E27FC236}">
+                <a16:creationId xmlns:a16="http://schemas.microsoft.com/office/drawing/2014/main" id="{9F88B35D-BF61-BC01-39F8-CA80CFFF0A4E}"/>
+              </a:ext>
+            </a:extLst>
+          </p:cNvPr>
+          <p:cNvPicPr>
+            <a:picLocks noChangeAspect="1"/>
+          </p:cNvPicPr>
+          <p:nvPr/>
+        </p:nvPicPr>
+        <p:blipFill>
+          <a:blip r:embed="rId5"/>
+          <a:stretch>
+            <a:fillRect/>
+          </a:stretch>
+        </p:blipFill>
+        <p:spPr>
+          <a:xfrm>
+            <a:off x="8354622" y="267789"/>
+            <a:ext cx="469338" cy="480060"/>
+          </a:xfrm>
+          <a:prstGeom prst="rect">
+            <a:avLst/>
+          </a:prstGeom>
+        </p:spPr>
+      </p:pic>
     </p:spTree>
   </p:cSld>
   <p:clrMapOvr>
@@ -14999,6 +15078,36 @@
           </a:p>
         </p:txBody>
       </p:sp>
+      <p:pic>
+        <p:nvPicPr>
+          <p:cNvPr id="18" name="Imagem 17">
+            <a:extLst>
+              <a:ext uri="{FF2B5EF4-FFF2-40B4-BE49-F238E27FC236}">
+                <a16:creationId xmlns:a16="http://schemas.microsoft.com/office/drawing/2014/main" id="{79344C0F-5095-7403-F741-7BFC3906596A}"/>
+              </a:ext>
+            </a:extLst>
+          </p:cNvPr>
+          <p:cNvPicPr>
+            <a:picLocks noChangeAspect="1"/>
+          </p:cNvPicPr>
+          <p:nvPr/>
+        </p:nvPicPr>
+        <p:blipFill>
+          <a:blip r:embed="rId4"/>
+          <a:stretch>
+            <a:fillRect/>
+          </a:stretch>
+        </p:blipFill>
+        <p:spPr>
+          <a:xfrm>
+            <a:off x="8354622" y="267789"/>
+            <a:ext cx="469338" cy="480060"/>
+          </a:xfrm>
+          <a:prstGeom prst="rect">
+            <a:avLst/>
+          </a:prstGeom>
+        </p:spPr>
+      </p:pic>
     </p:spTree>
   </p:cSld>
   <p:clrMapOvr>
@@ -15717,6 +15826,36 @@
           </a:p>
         </p:txBody>
       </p:sp>
+      <p:pic>
+        <p:nvPicPr>
+          <p:cNvPr id="15" name="Imagem 14">
+            <a:extLst>
+              <a:ext uri="{FF2B5EF4-FFF2-40B4-BE49-F238E27FC236}">
+                <a16:creationId xmlns:a16="http://schemas.microsoft.com/office/drawing/2014/main" id="{6375A03D-2B9B-CDAB-CB7B-18D351695029}"/>
+              </a:ext>
+            </a:extLst>
+          </p:cNvPr>
+          <p:cNvPicPr>
+            <a:picLocks noChangeAspect="1"/>
+          </p:cNvPicPr>
+          <p:nvPr/>
+        </p:nvPicPr>
+        <p:blipFill>
+          <a:blip r:embed="rId3"/>
+          <a:stretch>
+            <a:fillRect/>
+          </a:stretch>
+        </p:blipFill>
+        <p:spPr>
+          <a:xfrm>
+            <a:off x="8354622" y="267789"/>
+            <a:ext cx="469338" cy="480060"/>
+          </a:xfrm>
+          <a:prstGeom prst="rect">
+            <a:avLst/>
+          </a:prstGeom>
+        </p:spPr>
+      </p:pic>
     </p:spTree>
   </p:cSld>
   <p:clrMapOvr>
@@ -16509,6 +16648,36 @@
           </a:p>
         </p:txBody>
       </p:sp>
+      <p:pic>
+        <p:nvPicPr>
+          <p:cNvPr id="17" name="Imagem 16">
+            <a:extLst>
+              <a:ext uri="{FF2B5EF4-FFF2-40B4-BE49-F238E27FC236}">
+                <a16:creationId xmlns:a16="http://schemas.microsoft.com/office/drawing/2014/main" id="{864D924E-141F-76EA-EB11-86C1FE2CDEBE}"/>
+              </a:ext>
+            </a:extLst>
+          </p:cNvPr>
+          <p:cNvPicPr>
+            <a:picLocks noChangeAspect="1"/>
+          </p:cNvPicPr>
+          <p:nvPr/>
+        </p:nvPicPr>
+        <p:blipFill>
+          <a:blip r:embed="rId5"/>
+          <a:stretch>
+            <a:fillRect/>
+          </a:stretch>
+        </p:blipFill>
+        <p:spPr>
+          <a:xfrm>
+            <a:off x="8354622" y="267789"/>
+            <a:ext cx="469338" cy="480060"/>
+          </a:xfrm>
+          <a:prstGeom prst="rect">
+            <a:avLst/>
+          </a:prstGeom>
+        </p:spPr>
+      </p:pic>
     </p:spTree>
   </p:cSld>
   <p:clrMapOvr>

</xml_diff>

<commit_message>
feat: add DogFlush project presentation slide deck
</commit_message>
<xml_diff>
--- a/Projeto/DogFlush_Apresentacao.pptx
+++ b/Projeto/DogFlush_Apresentacao.pptx
@@ -11225,7 +11225,7 @@
               <a:buNone/>
             </a:pPr>
             <a:r>
-              <a:rPr lang="en-US" sz="1300" dirty="0">
+              <a:rPr lang="en-US" sz="1200" dirty="0">
                 <a:solidFill>
                   <a:srgbClr val="2E4A40"/>
                 </a:solidFill>
@@ -11236,7 +11236,7 @@
               <a:t>Donos de pets que trabalham/estudam passam </a:t>
             </a:r>
             <a:r>
-              <a:rPr lang="en-US" sz="1300" b="1" dirty="0">
+              <a:rPr lang="en-US" sz="1200" b="1" dirty="0">
                 <a:solidFill>
                   <a:srgbClr val="00897B"/>
                 </a:solidFill>
@@ -11247,7 +11247,7 @@
               <a:t>12+ horas fora de casa</a:t>
             </a:r>
             <a:r>
-              <a:rPr lang="en-US" sz="1300" dirty="0">
+              <a:rPr lang="en-US" sz="1200" dirty="0">
                 <a:solidFill>
                   <a:srgbClr val="2E4A40"/>
                 </a:solidFill>
@@ -11255,18 +11255,215 @@
                 <a:ea typeface="Calibri" pitchFamily="34" charset="-122"/>
                 <a:cs typeface="Calibri" pitchFamily="34" charset="-120"/>
               </a:rPr>
-              <a:t>. O espaço sanitário dos animais acumula sujeira, gerando:</a:t>
-            </a:r>
-            <a:endParaRPr lang="en-US" sz="1300" dirty="0"/>
-          </a:p>
-          <a:p>
-            <a:pPr marL="0" indent="0">
+              <a:t>. O espaço sanitário dos animais </a:t>
+            </a:r>
+            <a:r>
+              <a:rPr lang="en-US" sz="1200" dirty="0" err="1">
+                <a:solidFill>
+                  <a:srgbClr val="2E4A40"/>
+                </a:solidFill>
+                <a:latin typeface="Calibri" pitchFamily="34" charset="0"/>
+                <a:ea typeface="Calibri" pitchFamily="34" charset="-122"/>
+                <a:cs typeface="Calibri" pitchFamily="34" charset="-120"/>
+              </a:rPr>
+              <a:t>acumula</a:t>
+            </a:r>
+            <a:r>
+              <a:rPr lang="en-US" sz="1200" dirty="0">
+                <a:solidFill>
+                  <a:srgbClr val="2E4A40"/>
+                </a:solidFill>
+                <a:latin typeface="Calibri" pitchFamily="34" charset="0"/>
+                <a:ea typeface="Calibri" pitchFamily="34" charset="-122"/>
+                <a:cs typeface="Calibri" pitchFamily="34" charset="-120"/>
+              </a:rPr>
+              <a:t> </a:t>
+            </a:r>
+            <a:r>
+              <a:rPr lang="en-US" sz="1200" dirty="0" err="1">
+                <a:solidFill>
+                  <a:srgbClr val="2E4A40"/>
+                </a:solidFill>
+                <a:latin typeface="Calibri" pitchFamily="34" charset="0"/>
+                <a:ea typeface="Calibri" pitchFamily="34" charset="-122"/>
+                <a:cs typeface="Calibri" pitchFamily="34" charset="-120"/>
+              </a:rPr>
+              <a:t>sujeira</a:t>
+            </a:r>
+            <a:r>
+              <a:rPr lang="en-US" sz="1200" dirty="0">
+                <a:solidFill>
+                  <a:srgbClr val="2E4A40"/>
+                </a:solidFill>
+                <a:latin typeface="Calibri" pitchFamily="34" charset="0"/>
+                <a:ea typeface="Calibri" pitchFamily="34" charset="-122"/>
+                <a:cs typeface="Calibri" pitchFamily="34" charset="-120"/>
+              </a:rPr>
+              <a:t>. </a:t>
+            </a:r>
+            <a:r>
+              <a:rPr lang="en-US" sz="1200" dirty="0" err="1">
+                <a:solidFill>
+                  <a:srgbClr val="2E4A40"/>
+                </a:solidFill>
+                <a:latin typeface="Calibri" pitchFamily="34" charset="0"/>
+                <a:ea typeface="Calibri" pitchFamily="34" charset="-122"/>
+                <a:cs typeface="Calibri" pitchFamily="34" charset="-120"/>
+              </a:rPr>
+              <a:t>Soluções</a:t>
+            </a:r>
+            <a:r>
+              <a:rPr lang="en-US" sz="1200" dirty="0">
+                <a:solidFill>
+                  <a:srgbClr val="2E4A40"/>
+                </a:solidFill>
+                <a:latin typeface="Calibri" pitchFamily="34" charset="0"/>
+                <a:ea typeface="Calibri" pitchFamily="34" charset="-122"/>
+                <a:cs typeface="Calibri" pitchFamily="34" charset="-120"/>
+              </a:rPr>
+              <a:t> para gatos </a:t>
+            </a:r>
+            <a:r>
+              <a:rPr lang="en-US" sz="1200" dirty="0" err="1">
+                <a:solidFill>
+                  <a:srgbClr val="2E4A40"/>
+                </a:solidFill>
+                <a:latin typeface="Calibri" pitchFamily="34" charset="0"/>
+                <a:ea typeface="Calibri" pitchFamily="34" charset="-122"/>
+                <a:cs typeface="Calibri" pitchFamily="34" charset="-120"/>
+              </a:rPr>
+              <a:t>existem</a:t>
+            </a:r>
+            <a:r>
+              <a:rPr lang="en-US" sz="1200" dirty="0">
+                <a:solidFill>
+                  <a:srgbClr val="2E4A40"/>
+                </a:solidFill>
+                <a:latin typeface="Calibri" pitchFamily="34" charset="0"/>
+                <a:ea typeface="Calibri" pitchFamily="34" charset="-122"/>
+                <a:cs typeface="Calibri" pitchFamily="34" charset="-120"/>
+              </a:rPr>
+              <a:t>, mas para </a:t>
+            </a:r>
+            <a:r>
+              <a:rPr lang="en-US" sz="1200" dirty="0" err="1">
+                <a:solidFill>
+                  <a:srgbClr val="2E4A40"/>
+                </a:solidFill>
+                <a:latin typeface="Calibri" pitchFamily="34" charset="0"/>
+                <a:ea typeface="Calibri" pitchFamily="34" charset="-122"/>
+                <a:cs typeface="Calibri" pitchFamily="34" charset="-120"/>
+              </a:rPr>
+              <a:t>cães</a:t>
+            </a:r>
+            <a:r>
+              <a:rPr lang="en-US" sz="1200" dirty="0">
+                <a:solidFill>
+                  <a:srgbClr val="2E4A40"/>
+                </a:solidFill>
+                <a:latin typeface="Calibri" pitchFamily="34" charset="0"/>
+                <a:ea typeface="Calibri" pitchFamily="34" charset="-122"/>
+                <a:cs typeface="Calibri" pitchFamily="34" charset="-120"/>
+              </a:rPr>
+              <a:t> </a:t>
+            </a:r>
+            <a:r>
+              <a:rPr lang="en-US" sz="1200" dirty="0" err="1">
+                <a:solidFill>
+                  <a:srgbClr val="2E4A40"/>
+                </a:solidFill>
+                <a:latin typeface="Calibri" pitchFamily="34" charset="0"/>
+                <a:ea typeface="Calibri" pitchFamily="34" charset="-122"/>
+                <a:cs typeface="Calibri" pitchFamily="34" charset="-120"/>
+              </a:rPr>
+              <a:t>são</a:t>
+            </a:r>
+            <a:r>
+              <a:rPr lang="en-US" sz="1200" dirty="0">
+                <a:solidFill>
+                  <a:srgbClr val="2E4A40"/>
+                </a:solidFill>
+                <a:latin typeface="Calibri" pitchFamily="34" charset="0"/>
+                <a:ea typeface="Calibri" pitchFamily="34" charset="-122"/>
+                <a:cs typeface="Calibri" pitchFamily="34" charset="-120"/>
+              </a:rPr>
+              <a:t> </a:t>
+            </a:r>
+            <a:r>
+              <a:rPr lang="en-US" sz="1200" dirty="0" err="1">
+                <a:solidFill>
+                  <a:srgbClr val="2E4A40"/>
+                </a:solidFill>
+                <a:latin typeface="Calibri" pitchFamily="34" charset="0"/>
+                <a:ea typeface="Calibri" pitchFamily="34" charset="-122"/>
+                <a:cs typeface="Calibri" pitchFamily="34" charset="-120"/>
+              </a:rPr>
+              <a:t>praticamente</a:t>
+            </a:r>
+            <a:r>
+              <a:rPr lang="en-US" sz="1200" dirty="0">
+                <a:solidFill>
+                  <a:srgbClr val="2E4A40"/>
+                </a:solidFill>
+                <a:latin typeface="Calibri" pitchFamily="34" charset="0"/>
+                <a:ea typeface="Calibri" pitchFamily="34" charset="-122"/>
+                <a:cs typeface="Calibri" pitchFamily="34" charset="-120"/>
+              </a:rPr>
+              <a:t> </a:t>
+            </a:r>
+            <a:r>
+              <a:rPr lang="en-US" sz="1200" dirty="0" err="1">
+                <a:solidFill>
+                  <a:srgbClr val="2E4A40"/>
+                </a:solidFill>
+                <a:latin typeface="Calibri" pitchFamily="34" charset="0"/>
+                <a:ea typeface="Calibri" pitchFamily="34" charset="-122"/>
+                <a:cs typeface="Calibri" pitchFamily="34" charset="-120"/>
+              </a:rPr>
+              <a:t>inexistentes</a:t>
+            </a:r>
+            <a:r>
+              <a:rPr lang="en-US" sz="1200" dirty="0">
+                <a:solidFill>
+                  <a:srgbClr val="2E4A40"/>
+                </a:solidFill>
+                <a:latin typeface="Calibri" pitchFamily="34" charset="0"/>
+                <a:ea typeface="Calibri" pitchFamily="34" charset="-122"/>
+                <a:cs typeface="Calibri" pitchFamily="34" charset="-120"/>
+              </a:rPr>
+              <a:t> no </a:t>
+            </a:r>
+            <a:r>
+              <a:rPr lang="en-US" sz="1200" dirty="0" err="1">
+                <a:solidFill>
+                  <a:srgbClr val="2E4A40"/>
+                </a:solidFill>
+                <a:latin typeface="Calibri" pitchFamily="34" charset="0"/>
+                <a:ea typeface="Calibri" pitchFamily="34" charset="-122"/>
+                <a:cs typeface="Calibri" pitchFamily="34" charset="-120"/>
+              </a:rPr>
+              <a:t>Brasil</a:t>
+            </a:r>
+            <a:r>
+              <a:rPr lang="en-US" sz="1200" dirty="0">
+                <a:solidFill>
+                  <a:srgbClr val="2E4A40"/>
+                </a:solidFill>
+                <a:latin typeface="Calibri" pitchFamily="34" charset="0"/>
+                <a:ea typeface="Calibri" pitchFamily="34" charset="-122"/>
+                <a:cs typeface="Calibri" pitchFamily="34" charset="-120"/>
+              </a:rPr>
+              <a:t>.</a:t>
+            </a:r>
+            <a:endParaRPr lang="en-US" sz="1200" dirty="0"/>
+          </a:p>
+          <a:p>
+            <a:pPr>
               <a:lnSpc>
                 <a:spcPct val="130000"/>
               </a:lnSpc>
-              <a:buNone/>
-            </a:pPr>
-            <a:endParaRPr lang="en-US" sz="1300" dirty="0"/>
+            </a:pPr>
+            <a:endParaRPr lang="en-US" sz="1200" dirty="0"/>
           </a:p>
           <a:p>
             <a:pPr marL="342900" indent="-342900">
@@ -11277,7 +11474,7 @@
               <a:buChar char="•"/>
             </a:pPr>
             <a:r>
-              <a:rPr lang="en-US" sz="1300" dirty="0">
+              <a:rPr lang="en-US" sz="1200" dirty="0" err="1">
                 <a:solidFill>
                   <a:srgbClr val="2E4A40"/>
                 </a:solidFill>
@@ -11285,20 +11482,51 @@
                 <a:ea typeface="Calibri" pitchFamily="34" charset="-122"/>
                 <a:cs typeface="Calibri" pitchFamily="34" charset="-120"/>
               </a:rPr>
-              <a:t>Odores e contaminação bacteriana</a:t>
-            </a:r>
-            <a:endParaRPr lang="en-US" sz="1300" dirty="0"/>
-          </a:p>
-          <a:p>
-            <a:pPr marL="342900" indent="-342900">
+              <a:t>Produtos</a:t>
+            </a:r>
+            <a:r>
+              <a:rPr lang="en-US" sz="1200" dirty="0">
+                <a:solidFill>
+                  <a:srgbClr val="2E4A40"/>
+                </a:solidFill>
+                <a:latin typeface="Calibri" pitchFamily="34" charset="0"/>
+                <a:ea typeface="Calibri" pitchFamily="34" charset="-122"/>
+                <a:cs typeface="Calibri" pitchFamily="34" charset="-120"/>
+              </a:rPr>
+              <a:t> </a:t>
+            </a:r>
+            <a:r>
+              <a:rPr lang="en-US" sz="1200" dirty="0" err="1">
+                <a:solidFill>
+                  <a:srgbClr val="2E4A40"/>
+                </a:solidFill>
+                <a:latin typeface="Calibri" pitchFamily="34" charset="0"/>
+                <a:ea typeface="Calibri" pitchFamily="34" charset="-122"/>
+                <a:cs typeface="Calibri" pitchFamily="34" charset="-120"/>
+              </a:rPr>
+              <a:t>existentes</a:t>
+            </a:r>
+            <a:r>
+              <a:rPr lang="en-US" sz="1200" dirty="0">
+                <a:solidFill>
+                  <a:srgbClr val="2E4A40"/>
+                </a:solidFill>
+                <a:latin typeface="Calibri" pitchFamily="34" charset="0"/>
+                <a:ea typeface="Calibri" pitchFamily="34" charset="-122"/>
+                <a:cs typeface="Calibri" pitchFamily="34" charset="-120"/>
+              </a:rPr>
+              <a:t>: R$ 700+ </a:t>
+            </a:r>
+          </a:p>
+          <a:p>
+            <a:pPr>
               <a:lnSpc>
                 <a:spcPct val="130000"/>
               </a:lnSpc>
               <a:buSzPct val="100000"/>
-              <a:buChar char="•"/>
-            </a:pPr>
-            <a:r>
-              <a:rPr lang="en-US" sz="1300" dirty="0">
+            </a:pPr>
+            <a:r>
+              <a:rPr lang="en-US" sz="1200" dirty="0">
                 <a:solidFill>
                   <a:srgbClr val="2E4A40"/>
                 </a:solidFill>
@@ -11306,20 +11534,121 @@
                 <a:ea typeface="Calibri" pitchFamily="34" charset="-122"/>
                 <a:cs typeface="Calibri" pitchFamily="34" charset="-120"/>
               </a:rPr>
-              <a:t>Desconforto para o animal</a:t>
-            </a:r>
-            <a:endParaRPr lang="en-US" sz="1300" dirty="0"/>
-          </a:p>
-          <a:p>
-            <a:pPr marL="342900" indent="-342900">
+              <a:t>          (</a:t>
+            </a:r>
+            <a:r>
+              <a:rPr lang="en-US" sz="1200" dirty="0" err="1">
+                <a:solidFill>
+                  <a:srgbClr val="2E4A40"/>
+                </a:solidFill>
+                <a:latin typeface="Calibri" pitchFamily="34" charset="0"/>
+                <a:ea typeface="Calibri" pitchFamily="34" charset="-122"/>
+                <a:cs typeface="Calibri" pitchFamily="34" charset="-120"/>
+              </a:rPr>
+              <a:t>não-automatizados</a:t>
+            </a:r>
+            <a:r>
+              <a:rPr lang="en-US" sz="1200" dirty="0">
+                <a:solidFill>
+                  <a:srgbClr val="2E4A40"/>
+                </a:solidFill>
+                <a:latin typeface="Calibri" pitchFamily="34" charset="0"/>
+                <a:ea typeface="Calibri" pitchFamily="34" charset="-122"/>
+                <a:cs typeface="Calibri" pitchFamily="34" charset="-120"/>
+              </a:rPr>
+              <a:t>, </a:t>
+            </a:r>
+            <a:r>
+              <a:rPr lang="en-US" sz="1200" dirty="0" err="1">
+                <a:solidFill>
+                  <a:srgbClr val="2E4A40"/>
+                </a:solidFill>
+                <a:latin typeface="Calibri" pitchFamily="34" charset="0"/>
+                <a:ea typeface="Calibri" pitchFamily="34" charset="-122"/>
+                <a:cs typeface="Calibri" pitchFamily="34" charset="-120"/>
+              </a:rPr>
+              <a:t>apenas</a:t>
+            </a:r>
+            <a:r>
+              <a:rPr lang="en-US" sz="1200" dirty="0">
+                <a:solidFill>
+                  <a:srgbClr val="2E4A40"/>
+                </a:solidFill>
+                <a:latin typeface="Calibri" pitchFamily="34" charset="0"/>
+                <a:ea typeface="Calibri" pitchFamily="34" charset="-122"/>
+                <a:cs typeface="Calibri" pitchFamily="34" charset="-120"/>
+              </a:rPr>
+              <a:t> </a:t>
+            </a:r>
+            <a:r>
+              <a:rPr lang="en-US" sz="1200" dirty="0" err="1">
+                <a:solidFill>
+                  <a:srgbClr val="2E4A40"/>
+                </a:solidFill>
+                <a:latin typeface="Calibri" pitchFamily="34" charset="0"/>
+                <a:ea typeface="Calibri" pitchFamily="34" charset="-122"/>
+                <a:cs typeface="Calibri" pitchFamily="34" charset="-120"/>
+              </a:rPr>
+              <a:t>mangueira</a:t>
+            </a:r>
+            <a:r>
+              <a:rPr lang="en-US" sz="1200" dirty="0">
+                <a:solidFill>
+                  <a:srgbClr val="2E4A40"/>
+                </a:solidFill>
+                <a:latin typeface="Calibri" pitchFamily="34" charset="0"/>
+                <a:ea typeface="Calibri" pitchFamily="34" charset="-122"/>
+                <a:cs typeface="Calibri" pitchFamily="34" charset="-120"/>
+              </a:rPr>
+              <a:t> de </a:t>
+            </a:r>
+            <a:r>
+              <a:rPr lang="en-US" sz="1200" dirty="0" err="1">
+                <a:solidFill>
+                  <a:srgbClr val="2E4A40"/>
+                </a:solidFill>
+                <a:latin typeface="Calibri" pitchFamily="34" charset="0"/>
+                <a:ea typeface="Calibri" pitchFamily="34" charset="-122"/>
+                <a:cs typeface="Calibri" pitchFamily="34" charset="-120"/>
+              </a:rPr>
+              <a:t>saída</a:t>
+            </a:r>
+            <a:r>
+              <a:rPr lang="en-US" sz="1200" dirty="0">
+                <a:solidFill>
+                  <a:srgbClr val="2E4A40"/>
+                </a:solidFill>
+                <a:latin typeface="Calibri" pitchFamily="34" charset="0"/>
+                <a:ea typeface="Calibri" pitchFamily="34" charset="-122"/>
+                <a:cs typeface="Calibri" pitchFamily="34" charset="-120"/>
+              </a:rPr>
+              <a:t>)</a:t>
+            </a:r>
+            <a:endParaRPr lang="en-US" sz="1200" dirty="0"/>
+          </a:p>
+          <a:p>
+            <a:pPr>
               <a:lnSpc>
                 <a:spcPct val="130000"/>
               </a:lnSpc>
-              <a:buSzPct val="100000"/>
-              <a:buChar char="•"/>
-            </a:pPr>
-            <a:r>
-              <a:rPr lang="en-US" sz="1300" dirty="0">
+            </a:pPr>
+            <a:endParaRPr lang="en-US" sz="1200" b="1" dirty="0">
+              <a:solidFill>
+                <a:srgbClr val="2E4A40"/>
+              </a:solidFill>
+              <a:latin typeface="Calibri" pitchFamily="34" charset="0"/>
+              <a:ea typeface="Calibri" pitchFamily="34" charset="-122"/>
+              <a:cs typeface="Calibri" pitchFamily="34" charset="-120"/>
+            </a:endParaRPr>
+          </a:p>
+          <a:p>
+            <a:pPr>
+              <a:lnSpc>
+                <a:spcPct val="130000"/>
+              </a:lnSpc>
+            </a:pPr>
+            <a:r>
+              <a:rPr lang="en-US" sz="1200" b="1" dirty="0">
                 <a:solidFill>
                   <a:srgbClr val="2E4A40"/>
                 </a:solidFill>
@@ -11327,132 +11656,142 @@
                 <a:ea typeface="Calibri" pitchFamily="34" charset="-122"/>
                 <a:cs typeface="Calibri" pitchFamily="34" charset="-120"/>
               </a:rPr>
-              <a:t>Recusa em reutilizar o espaço sujo</a:t>
-            </a:r>
-            <a:endParaRPr lang="en-US" sz="1300" dirty="0"/>
-          </a:p>
-        </p:txBody>
-      </p:sp>
-      <p:sp>
-        <p:nvSpPr>
-          <p:cNvPr id="11" name="Shape 9"/>
-          <p:cNvSpPr/>
-          <p:nvPr/>
-        </p:nvSpPr>
-        <p:spPr>
-          <a:xfrm>
-            <a:off x="4754880" y="1051560"/>
-            <a:ext cx="3931920" cy="3291840"/>
-          </a:xfrm>
-          <a:prstGeom prst="rect">
-            <a:avLst/>
-          </a:prstGeom>
-          <a:solidFill>
-            <a:srgbClr val="FFFFFF"/>
-          </a:solidFill>
-          <a:ln/>
-          <a:effectLst>
-            <a:outerShdw blurRad="76200" dist="25400" dir="8100000" algn="bl" rotWithShape="0">
-              <a:srgbClr val="000000">
-                <a:alpha val="10000"/>
-              </a:srgbClr>
-            </a:outerShdw>
-          </a:effectLst>
-        </p:spPr>
-        <p:txBody>
-          <a:bodyPr/>
-          <a:lstStyle/>
-          <a:p>
-            <a:endParaRPr lang="pt-BR"/>
-          </a:p>
-        </p:txBody>
-      </p:sp>
-      <p:sp>
-        <p:nvSpPr>
-          <p:cNvPr id="12" name="Shape 10"/>
-          <p:cNvSpPr/>
-          <p:nvPr/>
-        </p:nvSpPr>
-        <p:spPr>
-          <a:xfrm>
-            <a:off x="4754880" y="1051560"/>
-            <a:ext cx="3931920" cy="54864"/>
-          </a:xfrm>
-          <a:prstGeom prst="rect">
-            <a:avLst/>
-          </a:prstGeom>
-          <a:solidFill>
-            <a:srgbClr val="F9A825"/>
-          </a:solidFill>
-          <a:ln/>
-        </p:spPr>
-        <p:txBody>
-          <a:bodyPr/>
-          <a:lstStyle/>
-          <a:p>
-            <a:endParaRPr lang="pt-BR"/>
-          </a:p>
-        </p:txBody>
-      </p:sp>
-      <p:sp>
-        <p:nvSpPr>
-          <p:cNvPr id="13" name="Text 11"/>
-          <p:cNvSpPr/>
-          <p:nvPr/>
-        </p:nvSpPr>
-        <p:spPr>
-          <a:xfrm>
-            <a:off x="4983480" y="1234440"/>
-            <a:ext cx="3474720" cy="411480"/>
-          </a:xfrm>
-          <a:prstGeom prst="rect">
-            <a:avLst/>
-          </a:prstGeom>
-          <a:noFill/>
-          <a:ln/>
-        </p:spPr>
-        <p:txBody>
-          <a:bodyPr wrap="square" lIns="0" tIns="0" rIns="0" bIns="0" rtlCol="0" anchor="ctr"/>
-          <a:lstStyle/>
-          <a:p>
-            <a:pPr marL="0" indent="0">
-              <a:buNone/>
-            </a:pPr>
-            <a:r>
-              <a:rPr lang="en-US" sz="1600" b="1" dirty="0">
-                <a:solidFill>
-                  <a:srgbClr val="003F2D"/>
-                </a:solidFill>
-                <a:latin typeface="Arial" pitchFamily="34" charset="0"/>
-                <a:ea typeface="Arial" pitchFamily="34" charset="-122"/>
-                <a:cs typeface="Arial" pitchFamily="34" charset="-120"/>
-              </a:rPr>
-              <a:t>Pesquisa de Mercado</a:t>
-            </a:r>
-            <a:endParaRPr lang="en-US" sz="1600" dirty="0"/>
-          </a:p>
-        </p:txBody>
-      </p:sp>
-      <p:sp>
-        <p:nvSpPr>
-          <p:cNvPr id="14" name="Text 12"/>
-          <p:cNvSpPr/>
-          <p:nvPr/>
-        </p:nvSpPr>
-        <p:spPr>
-          <a:xfrm>
-            <a:off x="4983480" y="1737360"/>
-            <a:ext cx="3474720" cy="2468880"/>
-          </a:xfrm>
-          <a:prstGeom prst="rect">
-            <a:avLst/>
-          </a:prstGeom>
-          <a:noFill/>
-          <a:ln/>
-        </p:spPr>
-        <p:txBody>
-          <a:bodyPr wrap="square" lIns="0" tIns="0" rIns="0" bIns="0" rtlCol="0" anchor="ctr"/>
-          <a:lstStyle/>
+              <a:t>Nossa </a:t>
+            </a:r>
+            <a:r>
+              <a:rPr lang="en-US" sz="1200" b="1" dirty="0" err="1">
+                <a:solidFill>
+                  <a:srgbClr val="2E4A40"/>
+                </a:solidFill>
+                <a:latin typeface="Calibri" pitchFamily="34" charset="0"/>
+                <a:ea typeface="Calibri" pitchFamily="34" charset="-122"/>
+                <a:cs typeface="Calibri" pitchFamily="34" charset="-120"/>
+              </a:rPr>
+              <a:t>proposta</a:t>
+            </a:r>
+            <a:r>
+              <a:rPr lang="en-US" sz="1200" b="1" dirty="0">
+                <a:solidFill>
+                  <a:srgbClr val="2E4A40"/>
+                </a:solidFill>
+                <a:latin typeface="Calibri" pitchFamily="34" charset="0"/>
+                <a:ea typeface="Calibri" pitchFamily="34" charset="-122"/>
+                <a:cs typeface="Calibri" pitchFamily="34" charset="-120"/>
+              </a:rPr>
+              <a:t>: </a:t>
+            </a:r>
+            <a:r>
+              <a:rPr lang="en-US" sz="1200" b="1" dirty="0" err="1">
+                <a:solidFill>
+                  <a:srgbClr val="2E4A40"/>
+                </a:solidFill>
+                <a:latin typeface="Calibri" pitchFamily="34" charset="0"/>
+                <a:ea typeface="Calibri" pitchFamily="34" charset="-122"/>
+                <a:cs typeface="Calibri" pitchFamily="34" charset="-120"/>
+              </a:rPr>
+              <a:t>visão</a:t>
+            </a:r>
+            <a:r>
+              <a:rPr lang="en-US" sz="1200" b="1" dirty="0">
+                <a:solidFill>
+                  <a:srgbClr val="2E4A40"/>
+                </a:solidFill>
+                <a:latin typeface="Calibri" pitchFamily="34" charset="0"/>
+                <a:ea typeface="Calibri" pitchFamily="34" charset="-122"/>
+                <a:cs typeface="Calibri" pitchFamily="34" charset="-120"/>
+              </a:rPr>
+              <a:t> </a:t>
+            </a:r>
+            <a:r>
+              <a:rPr lang="en-US" sz="1200" b="1" dirty="0" err="1">
+                <a:solidFill>
+                  <a:srgbClr val="2E4A40"/>
+                </a:solidFill>
+                <a:latin typeface="Calibri" pitchFamily="34" charset="0"/>
+                <a:ea typeface="Calibri" pitchFamily="34" charset="-122"/>
+                <a:cs typeface="Calibri" pitchFamily="34" charset="-120"/>
+              </a:rPr>
+              <a:t>computacional</a:t>
+            </a:r>
+            <a:r>
+              <a:rPr lang="en-US" sz="1200" b="1" dirty="0">
+                <a:solidFill>
+                  <a:srgbClr val="2E4A40"/>
+                </a:solidFill>
+                <a:latin typeface="Calibri" pitchFamily="34" charset="0"/>
+                <a:ea typeface="Calibri" pitchFamily="34" charset="-122"/>
+                <a:cs typeface="Calibri" pitchFamily="34" charset="-120"/>
+              </a:rPr>
+              <a:t> com webcam </a:t>
+            </a:r>
+            <a:r>
+              <a:rPr lang="en-US" sz="1200" b="1" dirty="0" err="1">
+                <a:solidFill>
+                  <a:srgbClr val="2E4A40"/>
+                </a:solidFill>
+                <a:latin typeface="Calibri" pitchFamily="34" charset="0"/>
+                <a:ea typeface="Calibri" pitchFamily="34" charset="-122"/>
+                <a:cs typeface="Calibri" pitchFamily="34" charset="-120"/>
+              </a:rPr>
+              <a:t>comum</a:t>
+            </a:r>
+            <a:r>
+              <a:rPr lang="en-US" sz="1200" b="1" dirty="0">
+                <a:solidFill>
+                  <a:srgbClr val="2E4A40"/>
+                </a:solidFill>
+                <a:latin typeface="Calibri" pitchFamily="34" charset="0"/>
+                <a:ea typeface="Calibri" pitchFamily="34" charset="-122"/>
+                <a:cs typeface="Calibri" pitchFamily="34" charset="-120"/>
+              </a:rPr>
+              <a:t> — </a:t>
+            </a:r>
+            <a:r>
+              <a:rPr lang="en-US" sz="1200" b="1" dirty="0" err="1">
+                <a:solidFill>
+                  <a:srgbClr val="2E4A40"/>
+                </a:solidFill>
+                <a:latin typeface="Calibri" pitchFamily="34" charset="0"/>
+                <a:ea typeface="Calibri" pitchFamily="34" charset="-122"/>
+                <a:cs typeface="Calibri" pitchFamily="34" charset="-120"/>
+              </a:rPr>
+              <a:t>acessível</a:t>
+            </a:r>
+            <a:r>
+              <a:rPr lang="en-US" sz="1200" b="1" dirty="0">
+                <a:solidFill>
+                  <a:srgbClr val="2E4A40"/>
+                </a:solidFill>
+                <a:latin typeface="Calibri" pitchFamily="34" charset="0"/>
+                <a:ea typeface="Calibri" pitchFamily="34" charset="-122"/>
+                <a:cs typeface="Calibri" pitchFamily="34" charset="-120"/>
+              </a:rPr>
+              <a:t> e </a:t>
+            </a:r>
+            <a:r>
+              <a:rPr lang="en-US" sz="1200" b="1" dirty="0" err="1">
+                <a:solidFill>
+                  <a:srgbClr val="2E4A40"/>
+                </a:solidFill>
+                <a:latin typeface="Calibri" pitchFamily="34" charset="0"/>
+                <a:ea typeface="Calibri" pitchFamily="34" charset="-122"/>
+                <a:cs typeface="Calibri" pitchFamily="34" charset="-120"/>
+              </a:rPr>
+              <a:t>sem</a:t>
+            </a:r>
+            <a:r>
+              <a:rPr lang="en-US" sz="1200" b="1" dirty="0">
+                <a:solidFill>
+                  <a:srgbClr val="2E4A40"/>
+                </a:solidFill>
+                <a:latin typeface="Calibri" pitchFamily="34" charset="0"/>
+                <a:ea typeface="Calibri" pitchFamily="34" charset="-122"/>
+                <a:cs typeface="Calibri" pitchFamily="34" charset="-120"/>
+              </a:rPr>
+              <a:t> hardware extra.</a:t>
+            </a:r>
+            <a:endParaRPr lang="en-US" sz="1200" dirty="0"/>
+          </a:p>
           <a:p>
             <a:pPr marL="0" indent="0">
               <a:lnSpc>
@@ -11460,98 +11799,7 @@
               </a:lnSpc>
               <a:buNone/>
             </a:pPr>
-            <a:r>
-              <a:rPr lang="en-US" sz="1300" dirty="0">
-                <a:solidFill>
-                  <a:srgbClr val="2E4A40"/>
-                </a:solidFill>
-                <a:latin typeface="Calibri" pitchFamily="34" charset="0"/>
-                <a:ea typeface="Calibri" pitchFamily="34" charset="-122"/>
-                <a:cs typeface="Calibri" pitchFamily="34" charset="-120"/>
-              </a:rPr>
-              <a:t>Soluções autolimpantes para gatos existem, mas para cães são praticamente inexistentes no Brasil.</a:t>
-            </a:r>
-            <a:endParaRPr lang="en-US" sz="1300" dirty="0"/>
-          </a:p>
-          <a:p>
-            <a:pPr marL="0" indent="0">
-              <a:lnSpc>
-                <a:spcPct val="130000"/>
-              </a:lnSpc>
-              <a:buNone/>
-            </a:pPr>
-            <a:endParaRPr lang="en-US" sz="1300" dirty="0"/>
-          </a:p>
-          <a:p>
-            <a:pPr marL="342900" indent="-342900">
-              <a:lnSpc>
-                <a:spcPct val="130000"/>
-              </a:lnSpc>
-              <a:buSzPct val="100000"/>
-              <a:buChar char="•"/>
-            </a:pPr>
-            <a:r>
-              <a:rPr lang="en-US" sz="1300" dirty="0">
-                <a:solidFill>
-                  <a:srgbClr val="2E4A40"/>
-                </a:solidFill>
-                <a:latin typeface="Calibri" pitchFamily="34" charset="0"/>
-                <a:ea typeface="Calibri" pitchFamily="34" charset="-122"/>
-                <a:cs typeface="Calibri" pitchFamily="34" charset="-120"/>
-              </a:rPr>
-              <a:t>Produtos existentes: R$ 900+ (não-automatizados)</a:t>
-            </a:r>
-            <a:endParaRPr lang="en-US" sz="1300" dirty="0"/>
-          </a:p>
-          <a:p>
-            <a:pPr marL="342900" indent="-342900">
-              <a:lnSpc>
-                <a:spcPct val="130000"/>
-              </a:lnSpc>
-              <a:buSzPct val="100000"/>
-              <a:buChar char="•"/>
-            </a:pPr>
-            <a:r>
-              <a:rPr lang="en-US" sz="1300" dirty="0">
-                <a:solidFill>
-                  <a:srgbClr val="2E4A40"/>
-                </a:solidFill>
-                <a:latin typeface="Calibri" pitchFamily="34" charset="0"/>
-                <a:ea typeface="Calibri" pitchFamily="34" charset="-122"/>
-                <a:cs typeface="Calibri" pitchFamily="34" charset="-120"/>
-              </a:rPr>
-              <a:t>Soluções automatizadas: R$ 2.000+ com hardware especial</a:t>
-            </a:r>
-            <a:endParaRPr lang="en-US" sz="1300" dirty="0"/>
-          </a:p>
-          <a:p>
-            <a:pPr marL="0" indent="0">
-              <a:lnSpc>
-                <a:spcPct val="130000"/>
-              </a:lnSpc>
-              <a:buNone/>
-            </a:pPr>
-            <a:endParaRPr lang="en-US" sz="1300" dirty="0"/>
-          </a:p>
-          <a:p>
-            <a:pPr marL="0" indent="0">
-              <a:lnSpc>
-                <a:spcPct val="130000"/>
-              </a:lnSpc>
-              <a:buNone/>
-            </a:pPr>
-            <a:r>
-              <a:rPr lang="en-US" sz="1300" b="1" dirty="0">
-                <a:solidFill>
-                  <a:srgbClr val="2E4A40"/>
-                </a:solidFill>
-                <a:latin typeface="Calibri" pitchFamily="34" charset="0"/>
-                <a:ea typeface="Calibri" pitchFamily="34" charset="-122"/>
-                <a:cs typeface="Calibri" pitchFamily="34" charset="-120"/>
-              </a:rPr>
-              <a:t>Nossa proposta: visão computacional com webcam comum — acessível e sem hardware extra.</a:t>
-            </a:r>
-            <a:endParaRPr lang="en-US" sz="1300" dirty="0"/>
+            <a:endParaRPr lang="en-US" sz="1200" dirty="0"/>
           </a:p>
         </p:txBody>
       </p:sp>
@@ -11583,6 +11831,46 @@
           <a:prstGeom prst="rect">
             <a:avLst/>
           </a:prstGeom>
+        </p:spPr>
+      </p:pic>
+      <p:pic>
+        <p:nvPicPr>
+          <p:cNvPr id="19" name="Imagem 18">
+            <a:extLst>
+              <a:ext uri="{FF2B5EF4-FFF2-40B4-BE49-F238E27FC236}">
+                <a16:creationId xmlns:a16="http://schemas.microsoft.com/office/drawing/2014/main" id="{F61D30A3-E851-0213-57B7-81718ED608EB}"/>
+              </a:ext>
+            </a:extLst>
+          </p:cNvPr>
+          <p:cNvPicPr>
+            <a:picLocks noChangeAspect="1"/>
+          </p:cNvPicPr>
+          <p:nvPr/>
+        </p:nvPicPr>
+        <p:blipFill>
+          <a:blip r:embed="rId4"/>
+          <a:stretch>
+            <a:fillRect/>
+          </a:stretch>
+        </p:blipFill>
+        <p:spPr>
+          <a:xfrm>
+            <a:off x="4617720" y="1328196"/>
+            <a:ext cx="4114802" cy="2738568"/>
+          </a:xfrm>
+          <a:prstGeom prst="rect">
+            <a:avLst/>
+          </a:prstGeom>
+          <a:ln>
+            <a:noFill/>
+          </a:ln>
+          <a:effectLst>
+            <a:outerShdw blurRad="292100" dist="139700" dir="2700000" algn="tl" rotWithShape="0">
+              <a:srgbClr val="333333">
+                <a:alpha val="65000"/>
+              </a:srgbClr>
+            </a:outerShdw>
+          </a:effectLst>
         </p:spPr>
       </p:pic>
     </p:spTree>

</xml_diff>